<commit_message>
Add citation-verification badge to the top of the PRD tab
</commit_message>
<xml_diff>
--- a/docs/SignalLoop_Deck.pptx
+++ b/docs/SignalLoop_Deck.pptx
@@ -5,19 +5,19 @@
     <p:sldMasterId id="2147483648" r:id="rId1"/>
   </p:sldMasterIdLst>
   <p:sldIdLst>
-    <p:sldId id="256" r:id="rId7"/>
-    <p:sldId id="257" r:id="rId8"/>
-    <p:sldId id="258" r:id="rId9"/>
-    <p:sldId id="259" r:id="rId10"/>
-    <p:sldId id="260" r:id="rId11"/>
-    <p:sldId id="261" r:id="rId12"/>
-    <p:sldId id="262" r:id="rId13"/>
-    <p:sldId id="263" r:id="rId14"/>
-    <p:sldId id="264" r:id="rId15"/>
-    <p:sldId id="265" r:id="rId16"/>
-    <p:sldId id="266" r:id="rId17"/>
+    <p:sldId id="256" r:id="rId2"/>
+    <p:sldId id="257" r:id="rId3"/>
+    <p:sldId id="258" r:id="rId4"/>
+    <p:sldId id="259" r:id="rId5"/>
+    <p:sldId id="260" r:id="rId6"/>
+    <p:sldId id="261" r:id="rId7"/>
+    <p:sldId id="262" r:id="rId8"/>
+    <p:sldId id="263" r:id="rId9"/>
+    <p:sldId id="264" r:id="rId10"/>
+    <p:sldId id="265" r:id="rId11"/>
+    <p:sldId id="266" r:id="rId12"/>
   </p:sldIdLst>
-  <p:sldSz cx="12191695" cy="6858000" type="screen4x3"/>
+  <p:sldSz cx="12192000" cy="6858000"/>
   <p:notesSz cx="6858000" cy="9144000"/>
   <p:defaultTextStyle>
     <a:defPPr>
@@ -114,6 +114,22 @@
       </a:defRPr>
     </a:lvl9pPr>
   </p:defaultTextStyle>
+  <p:extLst>
+    <p:ext uri="{EFAFB233-063F-42B5-8137-9DF3F51BA10A}">
+      <p15:sldGuideLst xmlns:p15="http://schemas.microsoft.com/office/powerpoint/2012/main">
+        <p15:guide id="1" orient="horz" pos="2160">
+          <p15:clr>
+            <a:srgbClr val="A4A3A4"/>
+          </p15:clr>
+        </p15:guide>
+        <p15:guide id="2" pos="2880">
+          <p15:clr>
+            <a:srgbClr val="A4A3A4"/>
+          </p15:clr>
+        </p15:guide>
+      </p15:sldGuideLst>
+    </p:ext>
+  </p:extLst>
 </p:presentation>
 </file>
 
@@ -155,10 +171,9 @@
           <a:lstStyle/>
           <a:p>
             <a:r>
-              <a:rPr lang="en-US" smtClean="0"/>
+              <a:rPr lang="en-US"/>
               <a:t>Click to edit Master title style</a:t>
             </a:r>
-            <a:endParaRPr lang="en-US"/>
           </a:p>
         </p:txBody>
       </p:sp>
@@ -274,10 +289,9 @@
           </a:lstStyle>
           <a:p>
             <a:r>
-              <a:rPr lang="en-US" smtClean="0"/>
+              <a:rPr lang="en-US"/>
               <a:t>Click to edit Master subtitle style</a:t>
             </a:r>
-            <a:endParaRPr lang="en-US"/>
           </a:p>
         </p:txBody>
       </p:sp>
@@ -298,7 +312,7 @@
           <a:p>
             <a:fld id="{5BCAD085-E8A6-8845-BD4E-CB4CCA059FC4}" type="datetimeFigureOut">
               <a:rPr lang="en-US" smtClean="0"/>
-              <a:t>1/27/13</a:t>
+              <a:t>6/15/2026</a:t>
             </a:fld>
             <a:endParaRPr lang="en-US"/>
           </a:p>
@@ -392,10 +406,9 @@
           <a:lstStyle/>
           <a:p>
             <a:r>
-              <a:rPr lang="en-US" smtClean="0"/>
+              <a:rPr lang="en-US"/>
               <a:t>Click to edit Master title style</a:t>
             </a:r>
-            <a:endParaRPr lang="en-US"/>
           </a:p>
         </p:txBody>
       </p:sp>
@@ -416,38 +429,37 @@
           <a:p>
             <a:pPr lvl="0"/>
             <a:r>
-              <a:rPr lang="en-US" smtClean="0"/>
+              <a:rPr lang="en-US"/>
               <a:t>Click to edit Master text styles</a:t>
             </a:r>
           </a:p>
           <a:p>
             <a:pPr lvl="1"/>
             <a:r>
-              <a:rPr lang="en-US" smtClean="0"/>
+              <a:rPr lang="en-US"/>
               <a:t>Second level</a:t>
             </a:r>
           </a:p>
           <a:p>
             <a:pPr lvl="2"/>
             <a:r>
-              <a:rPr lang="en-US" smtClean="0"/>
+              <a:rPr lang="en-US"/>
               <a:t>Third level</a:t>
             </a:r>
           </a:p>
           <a:p>
             <a:pPr lvl="3"/>
             <a:r>
-              <a:rPr lang="en-US" smtClean="0"/>
+              <a:rPr lang="en-US"/>
               <a:t>Fourth level</a:t>
             </a:r>
           </a:p>
           <a:p>
             <a:pPr lvl="4"/>
             <a:r>
-              <a:rPr lang="en-US" smtClean="0"/>
+              <a:rPr lang="en-US"/>
               <a:t>Fifth level</a:t>
             </a:r>
-            <a:endParaRPr lang="en-US"/>
           </a:p>
         </p:txBody>
       </p:sp>
@@ -468,7 +480,7 @@
           <a:p>
             <a:fld id="{5BCAD085-E8A6-8845-BD4E-CB4CCA059FC4}" type="datetimeFigureOut">
               <a:rPr lang="en-US" smtClean="0"/>
-              <a:t>1/27/13</a:t>
+              <a:t>6/15/2026</a:t>
             </a:fld>
             <a:endParaRPr lang="en-US"/>
           </a:p>
@@ -567,10 +579,9 @@
           <a:lstStyle/>
           <a:p>
             <a:r>
-              <a:rPr lang="en-US" smtClean="0"/>
+              <a:rPr lang="en-US"/>
               <a:t>Click to edit Master title style</a:t>
             </a:r>
-            <a:endParaRPr lang="en-US"/>
           </a:p>
         </p:txBody>
       </p:sp>
@@ -596,38 +607,37 @@
           <a:p>
             <a:pPr lvl="0"/>
             <a:r>
-              <a:rPr lang="en-US" smtClean="0"/>
+              <a:rPr lang="en-US"/>
               <a:t>Click to edit Master text styles</a:t>
             </a:r>
           </a:p>
           <a:p>
             <a:pPr lvl="1"/>
             <a:r>
-              <a:rPr lang="en-US" smtClean="0"/>
+              <a:rPr lang="en-US"/>
               <a:t>Second level</a:t>
             </a:r>
           </a:p>
           <a:p>
             <a:pPr lvl="2"/>
             <a:r>
-              <a:rPr lang="en-US" smtClean="0"/>
+              <a:rPr lang="en-US"/>
               <a:t>Third level</a:t>
             </a:r>
           </a:p>
           <a:p>
             <a:pPr lvl="3"/>
             <a:r>
-              <a:rPr lang="en-US" smtClean="0"/>
+              <a:rPr lang="en-US"/>
               <a:t>Fourth level</a:t>
             </a:r>
           </a:p>
           <a:p>
             <a:pPr lvl="4"/>
             <a:r>
-              <a:rPr lang="en-US" smtClean="0"/>
+              <a:rPr lang="en-US"/>
               <a:t>Fifth level</a:t>
             </a:r>
-            <a:endParaRPr lang="en-US"/>
           </a:p>
         </p:txBody>
       </p:sp>
@@ -648,7 +658,7 @@
           <a:p>
             <a:fld id="{5BCAD085-E8A6-8845-BD4E-CB4CCA059FC4}" type="datetimeFigureOut">
               <a:rPr lang="en-US" smtClean="0"/>
-              <a:t>1/27/13</a:t>
+              <a:t>6/15/2026</a:t>
             </a:fld>
             <a:endParaRPr lang="en-US"/>
           </a:p>
@@ -742,10 +752,9 @@
           <a:lstStyle/>
           <a:p>
             <a:r>
-              <a:rPr lang="en-US" smtClean="0"/>
+              <a:rPr lang="en-US"/>
               <a:t>Click to edit Master title style</a:t>
             </a:r>
-            <a:endParaRPr lang="en-US"/>
           </a:p>
         </p:txBody>
       </p:sp>
@@ -766,38 +775,37 @@
           <a:p>
             <a:pPr lvl="0"/>
             <a:r>
-              <a:rPr lang="en-US" smtClean="0"/>
+              <a:rPr lang="en-US"/>
               <a:t>Click to edit Master text styles</a:t>
             </a:r>
           </a:p>
           <a:p>
             <a:pPr lvl="1"/>
             <a:r>
-              <a:rPr lang="en-US" smtClean="0"/>
+              <a:rPr lang="en-US"/>
               <a:t>Second level</a:t>
             </a:r>
           </a:p>
           <a:p>
             <a:pPr lvl="2"/>
             <a:r>
-              <a:rPr lang="en-US" smtClean="0"/>
+              <a:rPr lang="en-US"/>
               <a:t>Third level</a:t>
             </a:r>
           </a:p>
           <a:p>
             <a:pPr lvl="3"/>
             <a:r>
-              <a:rPr lang="en-US" smtClean="0"/>
+              <a:rPr lang="en-US"/>
               <a:t>Fourth level</a:t>
             </a:r>
           </a:p>
           <a:p>
             <a:pPr lvl="4"/>
             <a:r>
-              <a:rPr lang="en-US" smtClean="0"/>
+              <a:rPr lang="en-US"/>
               <a:t>Fifth level</a:t>
             </a:r>
-            <a:endParaRPr lang="en-US"/>
           </a:p>
         </p:txBody>
       </p:sp>
@@ -818,7 +826,7 @@
           <a:p>
             <a:fld id="{5BCAD085-E8A6-8845-BD4E-CB4CCA059FC4}" type="datetimeFigureOut">
               <a:rPr lang="en-US" smtClean="0"/>
-              <a:t>1/27/13</a:t>
+              <a:t>6/15/2026</a:t>
             </a:fld>
             <a:endParaRPr lang="en-US"/>
           </a:p>
@@ -921,10 +929,9 @@
           </a:lstStyle>
           <a:p>
             <a:r>
-              <a:rPr lang="en-US" smtClean="0"/>
+              <a:rPr lang="en-US"/>
               <a:t>Click to edit Master title style</a:t>
             </a:r>
-            <a:endParaRPr lang="en-US"/>
           </a:p>
         </p:txBody>
       </p:sp>
@@ -1041,7 +1048,7 @@
           <a:p>
             <a:pPr lvl="0"/>
             <a:r>
-              <a:rPr lang="en-US" smtClean="0"/>
+              <a:rPr lang="en-US"/>
               <a:t>Click to edit Master text styles</a:t>
             </a:r>
           </a:p>
@@ -1064,7 +1071,7 @@
           <a:p>
             <a:fld id="{5BCAD085-E8A6-8845-BD4E-CB4CCA059FC4}" type="datetimeFigureOut">
               <a:rPr lang="en-US" smtClean="0"/>
-              <a:t>1/27/13</a:t>
+              <a:t>6/15/2026</a:t>
             </a:fld>
             <a:endParaRPr lang="en-US"/>
           </a:p>
@@ -1158,10 +1165,9 @@
           <a:lstStyle/>
           <a:p>
             <a:r>
-              <a:rPr lang="en-US" smtClean="0"/>
+              <a:rPr lang="en-US"/>
               <a:t>Click to edit Master title style</a:t>
             </a:r>
-            <a:endParaRPr lang="en-US"/>
           </a:p>
         </p:txBody>
       </p:sp>
@@ -1215,38 +1221,37 @@
           <a:p>
             <a:pPr lvl="0"/>
             <a:r>
-              <a:rPr lang="en-US" smtClean="0"/>
+              <a:rPr lang="en-US"/>
               <a:t>Click to edit Master text styles</a:t>
             </a:r>
           </a:p>
           <a:p>
             <a:pPr lvl="1"/>
             <a:r>
-              <a:rPr lang="en-US" smtClean="0"/>
+              <a:rPr lang="en-US"/>
               <a:t>Second level</a:t>
             </a:r>
           </a:p>
           <a:p>
             <a:pPr lvl="2"/>
             <a:r>
-              <a:rPr lang="en-US" smtClean="0"/>
+              <a:rPr lang="en-US"/>
               <a:t>Third level</a:t>
             </a:r>
           </a:p>
           <a:p>
             <a:pPr lvl="3"/>
             <a:r>
-              <a:rPr lang="en-US" smtClean="0"/>
+              <a:rPr lang="en-US"/>
               <a:t>Fourth level</a:t>
             </a:r>
           </a:p>
           <a:p>
             <a:pPr lvl="4"/>
             <a:r>
-              <a:rPr lang="en-US" smtClean="0"/>
+              <a:rPr lang="en-US"/>
               <a:t>Fifth level</a:t>
             </a:r>
-            <a:endParaRPr lang="en-US"/>
           </a:p>
         </p:txBody>
       </p:sp>
@@ -1300,38 +1305,37 @@
           <a:p>
             <a:pPr lvl="0"/>
             <a:r>
-              <a:rPr lang="en-US" smtClean="0"/>
+              <a:rPr lang="en-US"/>
               <a:t>Click to edit Master text styles</a:t>
             </a:r>
           </a:p>
           <a:p>
             <a:pPr lvl="1"/>
             <a:r>
-              <a:rPr lang="en-US" smtClean="0"/>
+              <a:rPr lang="en-US"/>
               <a:t>Second level</a:t>
             </a:r>
           </a:p>
           <a:p>
             <a:pPr lvl="2"/>
             <a:r>
-              <a:rPr lang="en-US" smtClean="0"/>
+              <a:rPr lang="en-US"/>
               <a:t>Third level</a:t>
             </a:r>
           </a:p>
           <a:p>
             <a:pPr lvl="3"/>
             <a:r>
-              <a:rPr lang="en-US" smtClean="0"/>
+              <a:rPr lang="en-US"/>
               <a:t>Fourth level</a:t>
             </a:r>
           </a:p>
           <a:p>
             <a:pPr lvl="4"/>
             <a:r>
-              <a:rPr lang="en-US" smtClean="0"/>
+              <a:rPr lang="en-US"/>
               <a:t>Fifth level</a:t>
             </a:r>
-            <a:endParaRPr lang="en-US"/>
           </a:p>
         </p:txBody>
       </p:sp>
@@ -1352,7 +1356,7 @@
           <a:p>
             <a:fld id="{5BCAD085-E8A6-8845-BD4E-CB4CCA059FC4}" type="datetimeFigureOut">
               <a:rPr lang="en-US" smtClean="0"/>
-              <a:t>1/27/13</a:t>
+              <a:t>6/15/2026</a:t>
             </a:fld>
             <a:endParaRPr lang="en-US"/>
           </a:p>
@@ -1450,10 +1454,9 @@
           </a:lstStyle>
           <a:p>
             <a:r>
-              <a:rPr lang="en-US" smtClean="0"/>
+              <a:rPr lang="en-US"/>
               <a:t>Click to edit Master title style</a:t>
             </a:r>
-            <a:endParaRPr lang="en-US"/>
           </a:p>
         </p:txBody>
       </p:sp>
@@ -1516,7 +1519,7 @@
           <a:p>
             <a:pPr lvl="0"/>
             <a:r>
-              <a:rPr lang="en-US" smtClean="0"/>
+              <a:rPr lang="en-US"/>
               <a:t>Click to edit Master text styles</a:t>
             </a:r>
           </a:p>
@@ -1572,38 +1575,37 @@
           <a:p>
             <a:pPr lvl="0"/>
             <a:r>
-              <a:rPr lang="en-US" smtClean="0"/>
+              <a:rPr lang="en-US"/>
               <a:t>Click to edit Master text styles</a:t>
             </a:r>
           </a:p>
           <a:p>
             <a:pPr lvl="1"/>
             <a:r>
-              <a:rPr lang="en-US" smtClean="0"/>
+              <a:rPr lang="en-US"/>
               <a:t>Second level</a:t>
             </a:r>
           </a:p>
           <a:p>
             <a:pPr lvl="2"/>
             <a:r>
-              <a:rPr lang="en-US" smtClean="0"/>
+              <a:rPr lang="en-US"/>
               <a:t>Third level</a:t>
             </a:r>
           </a:p>
           <a:p>
             <a:pPr lvl="3"/>
             <a:r>
-              <a:rPr lang="en-US" smtClean="0"/>
+              <a:rPr lang="en-US"/>
               <a:t>Fourth level</a:t>
             </a:r>
           </a:p>
           <a:p>
             <a:pPr lvl="4"/>
             <a:r>
-              <a:rPr lang="en-US" smtClean="0"/>
+              <a:rPr lang="en-US"/>
               <a:t>Fifth level</a:t>
             </a:r>
-            <a:endParaRPr lang="en-US"/>
           </a:p>
         </p:txBody>
       </p:sp>
@@ -1666,7 +1668,7 @@
           <a:p>
             <a:pPr lvl="0"/>
             <a:r>
-              <a:rPr lang="en-US" smtClean="0"/>
+              <a:rPr lang="en-US"/>
               <a:t>Click to edit Master text styles</a:t>
             </a:r>
           </a:p>
@@ -1722,38 +1724,37 @@
           <a:p>
             <a:pPr lvl="0"/>
             <a:r>
-              <a:rPr lang="en-US" smtClean="0"/>
+              <a:rPr lang="en-US"/>
               <a:t>Click to edit Master text styles</a:t>
             </a:r>
           </a:p>
           <a:p>
             <a:pPr lvl="1"/>
             <a:r>
-              <a:rPr lang="en-US" smtClean="0"/>
+              <a:rPr lang="en-US"/>
               <a:t>Second level</a:t>
             </a:r>
           </a:p>
           <a:p>
             <a:pPr lvl="2"/>
             <a:r>
-              <a:rPr lang="en-US" smtClean="0"/>
+              <a:rPr lang="en-US"/>
               <a:t>Third level</a:t>
             </a:r>
           </a:p>
           <a:p>
             <a:pPr lvl="3"/>
             <a:r>
-              <a:rPr lang="en-US" smtClean="0"/>
+              <a:rPr lang="en-US"/>
               <a:t>Fourth level</a:t>
             </a:r>
           </a:p>
           <a:p>
             <a:pPr lvl="4"/>
             <a:r>
-              <a:rPr lang="en-US" smtClean="0"/>
+              <a:rPr lang="en-US"/>
               <a:t>Fifth level</a:t>
             </a:r>
-            <a:endParaRPr lang="en-US"/>
           </a:p>
         </p:txBody>
       </p:sp>
@@ -1774,7 +1775,7 @@
           <a:p>
             <a:fld id="{5BCAD085-E8A6-8845-BD4E-CB4CCA059FC4}" type="datetimeFigureOut">
               <a:rPr lang="en-US" smtClean="0"/>
-              <a:t>1/27/13</a:t>
+              <a:t>6/15/2026</a:t>
             </a:fld>
             <a:endParaRPr lang="en-US"/>
           </a:p>
@@ -1868,10 +1869,9 @@
           <a:lstStyle/>
           <a:p>
             <a:r>
-              <a:rPr lang="en-US" smtClean="0"/>
+              <a:rPr lang="en-US"/>
               <a:t>Click to edit Master title style</a:t>
             </a:r>
-            <a:endParaRPr lang="en-US"/>
           </a:p>
         </p:txBody>
       </p:sp>
@@ -1892,7 +1892,7 @@
           <a:p>
             <a:fld id="{5BCAD085-E8A6-8845-BD4E-CB4CCA059FC4}" type="datetimeFigureOut">
               <a:rPr lang="en-US" smtClean="0"/>
-              <a:t>1/27/13</a:t>
+              <a:t>6/15/2026</a:t>
             </a:fld>
             <a:endParaRPr lang="en-US"/>
           </a:p>
@@ -1987,7 +1987,7 @@
           <a:p>
             <a:fld id="{5BCAD085-E8A6-8845-BD4E-CB4CCA059FC4}" type="datetimeFigureOut">
               <a:rPr lang="en-US" smtClean="0"/>
-              <a:t>1/27/13</a:t>
+              <a:t>6/15/2026</a:t>
             </a:fld>
             <a:endParaRPr lang="en-US"/>
           </a:p>
@@ -2090,10 +2090,9 @@
           </a:lstStyle>
           <a:p>
             <a:r>
-              <a:rPr lang="en-US" smtClean="0"/>
+              <a:rPr lang="en-US"/>
               <a:t>Click to edit Master title style</a:t>
             </a:r>
-            <a:endParaRPr lang="en-US"/>
           </a:p>
         </p:txBody>
       </p:sp>
@@ -2147,38 +2146,37 @@
           <a:p>
             <a:pPr lvl="0"/>
             <a:r>
-              <a:rPr lang="en-US" smtClean="0"/>
+              <a:rPr lang="en-US"/>
               <a:t>Click to edit Master text styles</a:t>
             </a:r>
           </a:p>
           <a:p>
             <a:pPr lvl="1"/>
             <a:r>
-              <a:rPr lang="en-US" smtClean="0"/>
+              <a:rPr lang="en-US"/>
               <a:t>Second level</a:t>
             </a:r>
           </a:p>
           <a:p>
             <a:pPr lvl="2"/>
             <a:r>
-              <a:rPr lang="en-US" smtClean="0"/>
+              <a:rPr lang="en-US"/>
               <a:t>Third level</a:t>
             </a:r>
           </a:p>
           <a:p>
             <a:pPr lvl="3"/>
             <a:r>
-              <a:rPr lang="en-US" smtClean="0"/>
+              <a:rPr lang="en-US"/>
               <a:t>Fourth level</a:t>
             </a:r>
           </a:p>
           <a:p>
             <a:pPr lvl="4"/>
             <a:r>
-              <a:rPr lang="en-US" smtClean="0"/>
+              <a:rPr lang="en-US"/>
               <a:t>Fifth level</a:t>
             </a:r>
-            <a:endParaRPr lang="en-US"/>
           </a:p>
         </p:txBody>
       </p:sp>
@@ -2241,7 +2239,7 @@
           <a:p>
             <a:pPr lvl="0"/>
             <a:r>
-              <a:rPr lang="en-US" smtClean="0"/>
+              <a:rPr lang="en-US"/>
               <a:t>Click to edit Master text styles</a:t>
             </a:r>
           </a:p>
@@ -2264,7 +2262,7 @@
           <a:p>
             <a:fld id="{5BCAD085-E8A6-8845-BD4E-CB4CCA059FC4}" type="datetimeFigureOut">
               <a:rPr lang="en-US" smtClean="0"/>
-              <a:t>1/27/13</a:t>
+              <a:t>6/15/2026</a:t>
             </a:fld>
             <a:endParaRPr lang="en-US"/>
           </a:p>
@@ -2367,10 +2365,9 @@
           </a:lstStyle>
           <a:p>
             <a:r>
-              <a:rPr lang="en-US" smtClean="0"/>
+              <a:rPr lang="en-US"/>
               <a:t>Click to edit Master title style</a:t>
             </a:r>
-            <a:endParaRPr lang="en-US"/>
           </a:p>
         </p:txBody>
       </p:sp>
@@ -2494,7 +2491,7 @@
           <a:p>
             <a:pPr lvl="0"/>
             <a:r>
-              <a:rPr lang="en-US" smtClean="0"/>
+              <a:rPr lang="en-US"/>
               <a:t>Click to edit Master text styles</a:t>
             </a:r>
           </a:p>
@@ -2517,7 +2514,7 @@
           <a:p>
             <a:fld id="{5BCAD085-E8A6-8845-BD4E-CB4CCA059FC4}" type="datetimeFigureOut">
               <a:rPr lang="en-US" smtClean="0"/>
-              <a:t>1/27/13</a:t>
+              <a:t>6/15/2026</a:t>
             </a:fld>
             <a:endParaRPr lang="en-US"/>
           </a:p>
@@ -2626,10 +2623,9 @@
           <a:lstStyle/>
           <a:p>
             <a:r>
-              <a:rPr lang="en-US" smtClean="0"/>
+              <a:rPr lang="en-US"/>
               <a:t>Click to edit Master title style</a:t>
             </a:r>
-            <a:endParaRPr lang="en-US"/>
           </a:p>
         </p:txBody>
       </p:sp>
@@ -2660,38 +2656,37 @@
           <a:p>
             <a:pPr lvl="0"/>
             <a:r>
-              <a:rPr lang="en-US" smtClean="0"/>
+              <a:rPr lang="en-US"/>
               <a:t>Click to edit Master text styles</a:t>
             </a:r>
           </a:p>
           <a:p>
             <a:pPr lvl="1"/>
             <a:r>
-              <a:rPr lang="en-US" smtClean="0"/>
+              <a:rPr lang="en-US"/>
               <a:t>Second level</a:t>
             </a:r>
           </a:p>
           <a:p>
             <a:pPr lvl="2"/>
             <a:r>
-              <a:rPr lang="en-US" smtClean="0"/>
+              <a:rPr lang="en-US"/>
               <a:t>Third level</a:t>
             </a:r>
           </a:p>
           <a:p>
             <a:pPr lvl="3"/>
             <a:r>
-              <a:rPr lang="en-US" smtClean="0"/>
+              <a:rPr lang="en-US"/>
               <a:t>Fourth level</a:t>
             </a:r>
           </a:p>
           <a:p>
             <a:pPr lvl="4"/>
             <a:r>
-              <a:rPr lang="en-US" smtClean="0"/>
+              <a:rPr lang="en-US"/>
               <a:t>Fifth level</a:t>
             </a:r>
-            <a:endParaRPr lang="en-US"/>
           </a:p>
         </p:txBody>
       </p:sp>
@@ -2730,7 +2725,7 @@
           <a:p>
             <a:fld id="{5BCAD085-E8A6-8845-BD4E-CB4CCA059FC4}" type="datetimeFigureOut">
               <a:rPr lang="en-US" smtClean="0"/>
-              <a:t>1/27/13</a:t>
+              <a:t>6/15/2026</a:t>
             </a:fld>
             <a:endParaRPr lang="en-US"/>
           </a:p>
@@ -3089,7 +3084,7 @@
 </file>
 
 <file path=ppt/slides/slide1.xml><?xml version="1.0" encoding="utf-8"?>
-<p:sld xmlns:a="http://schemas.openxmlformats.org/drawingml/2006/main" xmlns:p="http://schemas.openxmlformats.org/presentationml/2006/main" xmlns:r="http://schemas.openxmlformats.org/officeDocument/2006/relationships">
+<p:sld xmlns:a="http://schemas.openxmlformats.org/drawingml/2006/main" xmlns:r="http://schemas.openxmlformats.org/officeDocument/2006/relationships" xmlns:p="http://schemas.openxmlformats.org/presentationml/2006/main">
   <p:cSld>
     <p:bg>
       <p:bgPr>
@@ -3105,7 +3100,14 @@
         <p:cNvGrpSpPr/>
         <p:nvPr/>
       </p:nvGrpSpPr>
-      <p:grpSpPr/>
+      <p:grpSpPr>
+        <a:xfrm>
+          <a:off x="0" y="0"/>
+          <a:ext cx="0" cy="0"/>
+          <a:chOff x="0" y="0"/>
+          <a:chExt cx="0" cy="0"/>
+        </a:xfrm>
+      </p:grpSpPr>
       <p:sp>
         <p:nvSpPr>
           <p:cNvPr id="2" name="Oval 1"/>
@@ -3147,6 +3149,7 @@
           <a:lstStyle/>
           <a:p>
             <a:pPr algn="ctr"/>
+            <a:endParaRPr/>
           </a:p>
         </p:txBody>
       </p:sp>
@@ -3191,6 +3194,7 @@
           <a:lstStyle/>
           <a:p>
             <a:pPr algn="ctr"/>
+            <a:endParaRPr/>
           </a:p>
         </p:txBody>
       </p:sp>
@@ -3235,6 +3239,7 @@
           <a:lstStyle/>
           <a:p>
             <a:pPr algn="ctr"/>
+            <a:endParaRPr/>
           </a:p>
         </p:txBody>
       </p:sp>
@@ -3279,6 +3284,7 @@
           <a:lstStyle/>
           <a:p>
             <a:pPr algn="ctr"/>
+            <a:endParaRPr/>
           </a:p>
         </p:txBody>
       </p:sp>
@@ -3299,7 +3305,7 @@
           <a:noFill/>
         </p:spPr>
         <p:txBody>
-          <a:bodyPr wrap="square" anchor="t" lIns="45720" rIns="45720" tIns="18288" bIns="18288">
+          <a:bodyPr wrap="square" lIns="45720" tIns="18288" rIns="45720" bIns="18288" anchor="t">
             <a:spAutoFit/>
           </a:bodyPr>
           <a:lstStyle/>
@@ -3310,7 +3316,7 @@
               </a:spcAft>
             </a:pPr>
             <a:r>
-              <a:rPr sz="6600" b="1" i="0">
+              <a:rPr sz="6600" b="1" i="0" dirty="0" err="1">
                 <a:solidFill>
                   <a:srgbClr val="FFFFFF"/>
                 </a:solidFill>
@@ -3318,6 +3324,12 @@
               </a:rPr>
               <a:t>SignalLoop</a:t>
             </a:r>
+            <a:endParaRPr sz="6600" b="1" i="0" dirty="0">
+              <a:solidFill>
+                <a:srgbClr val="FFFFFF"/>
+              </a:solidFill>
+              <a:latin typeface="Segoe UI Semibold"/>
+            </a:endParaRPr>
           </a:p>
         </p:txBody>
       </p:sp>
@@ -3338,7 +3350,7 @@
           <a:noFill/>
         </p:spPr>
         <p:txBody>
-          <a:bodyPr wrap="square" anchor="t" lIns="45720" rIns="45720" tIns="18288" bIns="18288">
+          <a:bodyPr wrap="square" lIns="45720" tIns="18288" rIns="45720" bIns="18288" anchor="t">
             <a:spAutoFit/>
           </a:bodyPr>
           <a:lstStyle/>
@@ -3368,8 +3380,8 @@
         </p:nvSpPr>
         <p:spPr>
           <a:xfrm>
-            <a:off x="822960" y="4297680"/>
-            <a:ext cx="10058400" cy="457200"/>
+            <a:off x="822960" y="4206240"/>
+            <a:ext cx="10058400" cy="975652"/>
           </a:xfrm>
           <a:prstGeom prst="rect">
             <a:avLst/>
@@ -3377,7 +3389,7 @@
           <a:noFill/>
         </p:spPr>
         <p:txBody>
-          <a:bodyPr wrap="square" anchor="t" lIns="45720" rIns="45720" tIns="18288" bIns="18288">
+          <a:bodyPr wrap="square" lIns="45720" tIns="18288" rIns="45720" bIns="18288" anchor="t">
             <a:spAutoFit/>
           </a:bodyPr>
           <a:lstStyle/>
@@ -3388,7 +3400,7 @@
               </a:spcAft>
             </a:pPr>
             <a:r>
-              <a:rPr sz="1700" b="1" i="0">
+              <a:rPr sz="1700" b="1" i="0" dirty="0">
                 <a:solidFill>
                   <a:srgbClr val="FFFFFF"/>
                 </a:solidFill>
@@ -3404,13 +3416,35 @@
               </a:spcAft>
             </a:pPr>
             <a:r>
-              <a:rPr sz="1700" b="0" i="0">
+              <a:rPr sz="1700" b="0" i="0" dirty="0">
                 <a:solidFill>
                   <a:srgbClr val="D8D3F2"/>
                 </a:solidFill>
                 <a:latin typeface="Segoe UI"/>
               </a:rPr>
-              <a:t>  ·  Aspiring AI Product Manager</a:t>
+              <a:t>  Aspiring AI Product Manager</a:t>
+            </a:r>
+            <a:endParaRPr lang="en-IN" sz="1700" dirty="0">
+              <a:solidFill>
+                <a:srgbClr val="D8D3F2"/>
+              </a:solidFill>
+              <a:latin typeface="Segoe UI"/>
+            </a:endParaRPr>
+          </a:p>
+          <a:p>
+            <a:pPr algn="l">
+              <a:spcAft>
+                <a:spcPts val="600"/>
+              </a:spcAft>
+            </a:pPr>
+            <a:r>
+              <a:rPr lang="en-IN" sz="1700" b="0" i="0" dirty="0">
+                <a:solidFill>
+                  <a:srgbClr val="D8D3F2"/>
+                </a:solidFill>
+                <a:latin typeface="Segoe UI"/>
+              </a:rPr>
+              <a:t>  anuj.product.iitr@gmail.com</a:t>
             </a:r>
           </a:p>
         </p:txBody>
@@ -3432,7 +3466,7 @@
           <a:noFill/>
         </p:spPr>
         <p:txBody>
-          <a:bodyPr wrap="square" anchor="t" lIns="45720" rIns="45720" tIns="18288" bIns="18288">
+          <a:bodyPr wrap="square" lIns="45720" tIns="18288" rIns="45720" bIns="18288" anchor="t">
             <a:spAutoFit/>
           </a:bodyPr>
           <a:lstStyle/>
@@ -3463,7 +3497,7 @@
 </file>
 
 <file path=ppt/slides/slide10.xml><?xml version="1.0" encoding="utf-8"?>
-<p:sld xmlns:a="http://schemas.openxmlformats.org/drawingml/2006/main" xmlns:p="http://schemas.openxmlformats.org/presentationml/2006/main" xmlns:r="http://schemas.openxmlformats.org/officeDocument/2006/relationships">
+<p:sld xmlns:a="http://schemas.openxmlformats.org/drawingml/2006/main" xmlns:r="http://schemas.openxmlformats.org/officeDocument/2006/relationships" xmlns:p="http://schemas.openxmlformats.org/presentationml/2006/main">
   <p:cSld>
     <p:bg>
       <p:bgPr>
@@ -3479,7 +3513,14 @@
         <p:cNvGrpSpPr/>
         <p:nvPr/>
       </p:nvGrpSpPr>
-      <p:grpSpPr/>
+      <p:grpSpPr>
+        <a:xfrm>
+          <a:off x="0" y="0"/>
+          <a:ext cx="0" cy="0"/>
+          <a:chOff x="0" y="0"/>
+          <a:chExt cx="0" cy="0"/>
+        </a:xfrm>
+      </p:grpSpPr>
       <p:sp>
         <p:nvSpPr>
           <p:cNvPr id="2" name="Oval 1"/>
@@ -3521,6 +3562,7 @@
           <a:lstStyle/>
           <a:p>
             <a:pPr algn="ctr"/>
+            <a:endParaRPr/>
           </a:p>
         </p:txBody>
       </p:sp>
@@ -3541,7 +3583,7 @@
           <a:noFill/>
         </p:spPr>
         <p:txBody>
-          <a:bodyPr wrap="square" anchor="t" lIns="45720" rIns="45720" tIns="18288" bIns="18288">
+          <a:bodyPr wrap="square" lIns="45720" tIns="18288" rIns="45720" bIns="18288" anchor="t">
             <a:spAutoFit/>
           </a:bodyPr>
           <a:lstStyle/>
@@ -3580,7 +3622,7 @@
           <a:noFill/>
         </p:spPr>
         <p:txBody>
-          <a:bodyPr wrap="square" anchor="t" lIns="45720" rIns="45720" tIns="18288" bIns="18288">
+          <a:bodyPr wrap="square" lIns="45720" tIns="18288" rIns="45720" bIns="18288" anchor="t">
             <a:spAutoFit/>
           </a:bodyPr>
           <a:lstStyle/>
@@ -3641,7 +3683,9 @@
         <p:txBody>
           <a:bodyPr rtlCol="0" anchor="ctr"/>
           <a:lstStyle/>
-          <a:p/>
+          <a:p>
+            <a:endParaRPr/>
+          </a:p>
         </p:txBody>
       </p:sp>
       <p:sp>
@@ -3661,7 +3705,7 @@
           <a:noFill/>
         </p:spPr>
         <p:txBody>
-          <a:bodyPr wrap="square" anchor="t" lIns="45720" rIns="45720" tIns="18288" bIns="18288">
+          <a:bodyPr wrap="square" lIns="45720" tIns="18288" rIns="45720" bIns="18288" anchor="t">
             <a:spAutoFit/>
           </a:bodyPr>
           <a:lstStyle/>
@@ -3700,7 +3744,7 @@
           <a:noFill/>
         </p:spPr>
         <p:txBody>
-          <a:bodyPr wrap="square" anchor="t" lIns="45720" rIns="45720" tIns="18288" bIns="18288">
+          <a:bodyPr wrap="square" lIns="45720" tIns="18288" rIns="45720" bIns="18288" anchor="t">
             <a:spAutoFit/>
           </a:bodyPr>
           <a:lstStyle/>
@@ -3761,7 +3805,9 @@
         <p:txBody>
           <a:bodyPr rtlCol="0" anchor="ctr"/>
           <a:lstStyle/>
-          <a:p/>
+          <a:p>
+            <a:endParaRPr/>
+          </a:p>
         </p:txBody>
       </p:sp>
       <p:sp>
@@ -3781,7 +3827,7 @@
           <a:noFill/>
         </p:spPr>
         <p:txBody>
-          <a:bodyPr wrap="square" anchor="t" lIns="45720" rIns="45720" tIns="18288" bIns="18288">
+          <a:bodyPr wrap="square" lIns="45720" tIns="18288" rIns="45720" bIns="18288" anchor="t">
             <a:spAutoFit/>
           </a:bodyPr>
           <a:lstStyle/>
@@ -3820,7 +3866,7 @@
           <a:noFill/>
         </p:spPr>
         <p:txBody>
-          <a:bodyPr wrap="square" anchor="t" lIns="45720" rIns="45720" tIns="18288" bIns="18288">
+          <a:bodyPr wrap="square" lIns="45720" tIns="18288" rIns="45720" bIns="18288" anchor="t">
             <a:spAutoFit/>
           </a:bodyPr>
           <a:lstStyle/>
@@ -3881,7 +3927,9 @@
         <p:txBody>
           <a:bodyPr rtlCol="0" anchor="ctr"/>
           <a:lstStyle/>
-          <a:p/>
+          <a:p>
+            <a:endParaRPr/>
+          </a:p>
         </p:txBody>
       </p:sp>
       <p:sp>
@@ -3901,7 +3949,7 @@
           <a:noFill/>
         </p:spPr>
         <p:txBody>
-          <a:bodyPr wrap="square" anchor="t" lIns="45720" rIns="45720" tIns="18288" bIns="18288">
+          <a:bodyPr wrap="square" lIns="45720" tIns="18288" rIns="45720" bIns="18288" anchor="t">
             <a:spAutoFit/>
           </a:bodyPr>
           <a:lstStyle/>
@@ -3940,7 +3988,7 @@
           <a:noFill/>
         </p:spPr>
         <p:txBody>
-          <a:bodyPr wrap="square" anchor="t" lIns="45720" rIns="45720" tIns="18288" bIns="18288">
+          <a:bodyPr wrap="square" lIns="45720" tIns="18288" rIns="45720" bIns="18288" anchor="t">
             <a:spAutoFit/>
           </a:bodyPr>
           <a:lstStyle/>
@@ -3971,7 +4019,7 @@
 </file>
 
 <file path=ppt/slides/slide11.xml><?xml version="1.0" encoding="utf-8"?>
-<p:sld xmlns:a="http://schemas.openxmlformats.org/drawingml/2006/main" xmlns:p="http://schemas.openxmlformats.org/presentationml/2006/main" xmlns:r="http://schemas.openxmlformats.org/officeDocument/2006/relationships">
+<p:sld xmlns:a="http://schemas.openxmlformats.org/drawingml/2006/main" xmlns:r="http://schemas.openxmlformats.org/officeDocument/2006/relationships" xmlns:p="http://schemas.openxmlformats.org/presentationml/2006/main">
   <p:cSld>
     <p:bg>
       <p:bgPr>
@@ -3987,7 +4035,14 @@
         <p:cNvGrpSpPr/>
         <p:nvPr/>
       </p:nvGrpSpPr>
-      <p:grpSpPr/>
+      <p:grpSpPr>
+        <a:xfrm>
+          <a:off x="0" y="0"/>
+          <a:ext cx="0" cy="0"/>
+          <a:chOff x="0" y="0"/>
+          <a:chExt cx="0" cy="0"/>
+        </a:xfrm>
+      </p:grpSpPr>
       <p:sp>
         <p:nvSpPr>
           <p:cNvPr id="2" name="TextBox 1"/>
@@ -4005,7 +4060,7 @@
           <a:noFill/>
         </p:spPr>
         <p:txBody>
-          <a:bodyPr wrap="square" anchor="t" lIns="45720" rIns="45720" tIns="18288" bIns="18288">
+          <a:bodyPr wrap="square" lIns="45720" tIns="18288" rIns="45720" bIns="18288" anchor="t">
             <a:spAutoFit/>
           </a:bodyPr>
           <a:lstStyle/>
@@ -4044,7 +4099,7 @@
           <a:noFill/>
         </p:spPr>
         <p:txBody>
-          <a:bodyPr wrap="square" anchor="t" lIns="45720" rIns="45720" tIns="18288" bIns="18288">
+          <a:bodyPr wrap="square" lIns="45720" tIns="18288" rIns="45720" bIns="18288" anchor="t">
             <a:spAutoFit/>
           </a:bodyPr>
           <a:lstStyle/>
@@ -4083,7 +4138,7 @@
           <a:noFill/>
         </p:spPr>
         <p:txBody>
-          <a:bodyPr wrap="square" anchor="t" lIns="45720" rIns="45720" tIns="18288" bIns="18288">
+          <a:bodyPr wrap="square" lIns="45720" tIns="18288" rIns="45720" bIns="18288" anchor="t">
             <a:spAutoFit/>
           </a:bodyPr>
           <a:lstStyle/>
@@ -4122,7 +4177,7 @@
           <a:noFill/>
         </p:spPr>
         <p:txBody>
-          <a:bodyPr wrap="square" anchor="t" lIns="45720" rIns="45720" tIns="18288" bIns="18288">
+          <a:bodyPr wrap="square" lIns="45720" tIns="18288" rIns="45720" bIns="18288" anchor="t">
             <a:spAutoFit/>
           </a:bodyPr>
           <a:lstStyle/>
@@ -4161,7 +4216,7 @@
           <a:noFill/>
         </p:spPr>
         <p:txBody>
-          <a:bodyPr wrap="square" anchor="t" lIns="45720" rIns="45720" tIns="18288" bIns="18288">
+          <a:bodyPr wrap="square" lIns="45720" tIns="18288" rIns="45720" bIns="18288" anchor="t">
             <a:spAutoFit/>
           </a:bodyPr>
           <a:lstStyle/>
@@ -4200,7 +4255,7 @@
           <a:noFill/>
         </p:spPr>
         <p:txBody>
-          <a:bodyPr wrap="square" anchor="t" lIns="45720" rIns="45720" tIns="18288" bIns="18288">
+          <a:bodyPr wrap="square" lIns="45720" tIns="18288" rIns="45720" bIns="18288" anchor="t">
             <a:spAutoFit/>
           </a:bodyPr>
           <a:lstStyle/>
@@ -4239,7 +4294,7 @@
           <a:noFill/>
         </p:spPr>
         <p:txBody>
-          <a:bodyPr wrap="square" anchor="t" lIns="45720" rIns="45720" tIns="18288" bIns="18288">
+          <a:bodyPr wrap="square" lIns="45720" tIns="18288" rIns="45720" bIns="18288" anchor="t">
             <a:spAutoFit/>
           </a:bodyPr>
           <a:lstStyle/>
@@ -4278,7 +4333,7 @@
           <a:noFill/>
         </p:spPr>
         <p:txBody>
-          <a:bodyPr wrap="square" anchor="t" lIns="45720" rIns="45720" tIns="18288" bIns="18288">
+          <a:bodyPr wrap="square" lIns="45720" tIns="18288" rIns="45720" bIns="18288" anchor="t">
             <a:spAutoFit/>
           </a:bodyPr>
           <a:lstStyle/>
@@ -4317,7 +4372,7 @@
           <a:noFill/>
         </p:spPr>
         <p:txBody>
-          <a:bodyPr wrap="square" anchor="t" lIns="45720" rIns="45720" tIns="18288" bIns="18288">
+          <a:bodyPr wrap="square" lIns="45720" tIns="18288" rIns="45720" bIns="18288" anchor="t">
             <a:spAutoFit/>
           </a:bodyPr>
           <a:lstStyle/>
@@ -4348,7 +4403,7 @@
 </file>
 
 <file path=ppt/slides/slide2.xml><?xml version="1.0" encoding="utf-8"?>
-<p:sld xmlns:a="http://schemas.openxmlformats.org/drawingml/2006/main" xmlns:p="http://schemas.openxmlformats.org/presentationml/2006/main" xmlns:r="http://schemas.openxmlformats.org/officeDocument/2006/relationships">
+<p:sld xmlns:a="http://schemas.openxmlformats.org/drawingml/2006/main" xmlns:r="http://schemas.openxmlformats.org/officeDocument/2006/relationships" xmlns:p="http://schemas.openxmlformats.org/presentationml/2006/main">
   <p:cSld>
     <p:bg>
       <p:bgPr>
@@ -4364,7 +4419,14 @@
         <p:cNvGrpSpPr/>
         <p:nvPr/>
       </p:nvGrpSpPr>
-      <p:grpSpPr/>
+      <p:grpSpPr>
+        <a:xfrm>
+          <a:off x="0" y="0"/>
+          <a:ext cx="0" cy="0"/>
+          <a:chOff x="0" y="0"/>
+          <a:chExt cx="0" cy="0"/>
+        </a:xfrm>
+      </p:grpSpPr>
       <p:sp>
         <p:nvSpPr>
           <p:cNvPr id="2" name="Oval 1"/>
@@ -4406,6 +4468,7 @@
           <a:lstStyle/>
           <a:p>
             <a:pPr algn="ctr"/>
+            <a:endParaRPr/>
           </a:p>
         </p:txBody>
       </p:sp>
@@ -4426,7 +4489,7 @@
           <a:noFill/>
         </p:spPr>
         <p:txBody>
-          <a:bodyPr wrap="square" anchor="t" lIns="45720" rIns="45720" tIns="18288" bIns="18288">
+          <a:bodyPr wrap="square" lIns="45720" tIns="18288" rIns="45720" bIns="18288" anchor="t">
             <a:spAutoFit/>
           </a:bodyPr>
           <a:lstStyle/>
@@ -4465,7 +4528,7 @@
           <a:noFill/>
         </p:spPr>
         <p:txBody>
-          <a:bodyPr wrap="square" anchor="t" lIns="45720" rIns="45720" tIns="18288" bIns="18288">
+          <a:bodyPr wrap="square" lIns="45720" tIns="18288" rIns="45720" bIns="18288" anchor="t">
             <a:spAutoFit/>
           </a:bodyPr>
           <a:lstStyle/>
@@ -4504,7 +4567,7 @@
           <a:noFill/>
         </p:spPr>
         <p:txBody>
-          <a:bodyPr wrap="square" anchor="t" lIns="45720" rIns="45720" tIns="18288" bIns="18288">
+          <a:bodyPr wrap="square" lIns="45720" tIns="18288" rIns="45720" bIns="18288" anchor="t">
             <a:spAutoFit/>
           </a:bodyPr>
           <a:lstStyle/>
@@ -4583,7 +4646,9 @@
         <p:txBody>
           <a:bodyPr rtlCol="0" anchor="ctr"/>
           <a:lstStyle/>
-          <a:p/>
+          <a:p>
+            <a:endParaRPr/>
+          </a:p>
         </p:txBody>
       </p:sp>
       <p:sp>
@@ -4603,7 +4668,7 @@
           <a:noFill/>
         </p:spPr>
         <p:txBody>
-          <a:bodyPr wrap="square" anchor="t" lIns="45720" rIns="45720" tIns="18288" bIns="18288">
+          <a:bodyPr wrap="square" lIns="45720" tIns="18288" rIns="45720" bIns="18288" anchor="t">
             <a:spAutoFit/>
           </a:bodyPr>
           <a:lstStyle/>
@@ -4642,7 +4707,7 @@
           <a:noFill/>
         </p:spPr>
         <p:txBody>
-          <a:bodyPr wrap="square" anchor="t" lIns="45720" rIns="45720" tIns="18288" bIns="18288">
+          <a:bodyPr wrap="square" lIns="45720" tIns="18288" rIns="45720" bIns="18288" anchor="t">
             <a:spAutoFit/>
           </a:bodyPr>
           <a:lstStyle/>
@@ -4681,7 +4746,7 @@
           <a:noFill/>
         </p:spPr>
         <p:txBody>
-          <a:bodyPr wrap="square" anchor="t" lIns="45720" rIns="45720" tIns="18288" bIns="18288">
+          <a:bodyPr wrap="square" lIns="45720" tIns="18288" rIns="45720" bIns="18288" anchor="t">
             <a:spAutoFit/>
           </a:bodyPr>
           <a:lstStyle/>
@@ -4712,7 +4777,7 @@
 </file>
 
 <file path=ppt/slides/slide3.xml><?xml version="1.0" encoding="utf-8"?>
-<p:sld xmlns:a="http://schemas.openxmlformats.org/drawingml/2006/main" xmlns:p="http://schemas.openxmlformats.org/presentationml/2006/main" xmlns:r="http://schemas.openxmlformats.org/officeDocument/2006/relationships">
+<p:sld xmlns:a="http://schemas.openxmlformats.org/drawingml/2006/main" xmlns:r="http://schemas.openxmlformats.org/officeDocument/2006/relationships" xmlns:p="http://schemas.openxmlformats.org/presentationml/2006/main">
   <p:cSld>
     <p:bg>
       <p:bgPr>
@@ -4728,7 +4793,14 @@
         <p:cNvGrpSpPr/>
         <p:nvPr/>
       </p:nvGrpSpPr>
-      <p:grpSpPr/>
+      <p:grpSpPr>
+        <a:xfrm>
+          <a:off x="0" y="0"/>
+          <a:ext cx="0" cy="0"/>
+          <a:chOff x="0" y="0"/>
+          <a:chExt cx="0" cy="0"/>
+        </a:xfrm>
+      </p:grpSpPr>
       <p:sp>
         <p:nvSpPr>
           <p:cNvPr id="2" name="Oval 1"/>
@@ -4770,6 +4842,7 @@
           <a:lstStyle/>
           <a:p>
             <a:pPr algn="ctr"/>
+            <a:endParaRPr/>
           </a:p>
         </p:txBody>
       </p:sp>
@@ -4790,7 +4863,7 @@
           <a:noFill/>
         </p:spPr>
         <p:txBody>
-          <a:bodyPr wrap="square" anchor="t" lIns="45720" rIns="45720" tIns="18288" bIns="18288">
+          <a:bodyPr wrap="square" lIns="45720" tIns="18288" rIns="45720" bIns="18288" anchor="t">
             <a:spAutoFit/>
           </a:bodyPr>
           <a:lstStyle/>
@@ -4829,7 +4902,7 @@
           <a:noFill/>
         </p:spPr>
         <p:txBody>
-          <a:bodyPr wrap="square" anchor="t" lIns="45720" rIns="45720" tIns="18288" bIns="18288">
+          <a:bodyPr wrap="square" lIns="45720" tIns="18288" rIns="45720" bIns="18288" anchor="t">
             <a:spAutoFit/>
           </a:bodyPr>
           <a:lstStyle/>
@@ -4840,7 +4913,7 @@
               </a:spcAft>
             </a:pPr>
             <a:r>
-              <a:rPr sz="3400" b="1" i="0">
+              <a:rPr sz="3400" b="1" i="0" dirty="0">
                 <a:solidFill>
                   <a:srgbClr val="241B4B"/>
                 </a:solidFill>
@@ -4892,7 +4965,9 @@
         <p:txBody>
           <a:bodyPr rtlCol="0" anchor="ctr"/>
           <a:lstStyle/>
-          <a:p/>
+          <a:p>
+            <a:endParaRPr/>
+          </a:p>
         </p:txBody>
       </p:sp>
       <p:sp>
@@ -4934,7 +5009,9 @@
         <p:txBody>
           <a:bodyPr rtlCol="0" anchor="ctr"/>
           <a:lstStyle/>
-          <a:p/>
+          <a:p>
+            <a:endParaRPr/>
+          </a:p>
         </p:txBody>
       </p:sp>
       <p:sp>
@@ -4954,7 +5031,7 @@
           <a:noFill/>
         </p:spPr>
         <p:txBody>
-          <a:bodyPr wrap="square" anchor="t" lIns="45720" rIns="45720" tIns="18288" bIns="18288">
+          <a:bodyPr wrap="square" lIns="45720" tIns="18288" rIns="45720" bIns="18288" anchor="t">
             <a:spAutoFit/>
           </a:bodyPr>
           <a:lstStyle/>
@@ -4993,7 +5070,7 @@
           <a:noFill/>
         </p:spPr>
         <p:txBody>
-          <a:bodyPr wrap="square" anchor="t" lIns="45720" rIns="45720" tIns="18288" bIns="18288">
+          <a:bodyPr wrap="square" lIns="45720" tIns="18288" rIns="45720" bIns="18288" anchor="t">
             <a:spAutoFit/>
           </a:bodyPr>
           <a:lstStyle/>
@@ -5033,7 +5110,7 @@
           <a:noFill/>
         </p:spPr>
         <p:txBody>
-          <a:bodyPr wrap="square" anchor="t" lIns="45720" rIns="45720" tIns="18288" bIns="18288">
+          <a:bodyPr wrap="square" lIns="45720" tIns="18288" rIns="45720" bIns="18288" anchor="t">
             <a:spAutoFit/>
           </a:bodyPr>
           <a:lstStyle/>
@@ -5096,7 +5173,9 @@
         <p:txBody>
           <a:bodyPr rtlCol="0" anchor="ctr"/>
           <a:lstStyle/>
-          <a:p/>
+          <a:p>
+            <a:endParaRPr/>
+          </a:p>
         </p:txBody>
       </p:sp>
       <p:sp>
@@ -5138,7 +5217,9 @@
         <p:txBody>
           <a:bodyPr rtlCol="0" anchor="ctr"/>
           <a:lstStyle/>
-          <a:p/>
+          <a:p>
+            <a:endParaRPr/>
+          </a:p>
         </p:txBody>
       </p:sp>
       <p:sp>
@@ -5158,7 +5239,7 @@
           <a:noFill/>
         </p:spPr>
         <p:txBody>
-          <a:bodyPr wrap="square" anchor="t" lIns="45720" rIns="45720" tIns="18288" bIns="18288">
+          <a:bodyPr wrap="square" lIns="45720" tIns="18288" rIns="45720" bIns="18288" anchor="t">
             <a:spAutoFit/>
           </a:bodyPr>
           <a:lstStyle/>
@@ -5197,7 +5278,7 @@
           <a:noFill/>
         </p:spPr>
         <p:txBody>
-          <a:bodyPr wrap="square" anchor="t" lIns="45720" rIns="45720" tIns="18288" bIns="18288">
+          <a:bodyPr wrap="square" lIns="45720" tIns="18288" rIns="45720" bIns="18288" anchor="t">
             <a:spAutoFit/>
           </a:bodyPr>
           <a:lstStyle/>
@@ -5237,7 +5318,7 @@
           <a:noFill/>
         </p:spPr>
         <p:txBody>
-          <a:bodyPr wrap="square" anchor="t" lIns="45720" rIns="45720" tIns="18288" bIns="18288">
+          <a:bodyPr wrap="square" lIns="45720" tIns="18288" rIns="45720" bIns="18288" anchor="t">
             <a:spAutoFit/>
           </a:bodyPr>
           <a:lstStyle/>
@@ -5300,7 +5381,9 @@
         <p:txBody>
           <a:bodyPr rtlCol="0" anchor="ctr"/>
           <a:lstStyle/>
-          <a:p/>
+          <a:p>
+            <a:endParaRPr/>
+          </a:p>
         </p:txBody>
       </p:sp>
       <p:sp>
@@ -5342,7 +5425,9 @@
         <p:txBody>
           <a:bodyPr rtlCol="0" anchor="ctr"/>
           <a:lstStyle/>
-          <a:p/>
+          <a:p>
+            <a:endParaRPr/>
+          </a:p>
         </p:txBody>
       </p:sp>
       <p:sp>
@@ -5362,7 +5447,7 @@
           <a:noFill/>
         </p:spPr>
         <p:txBody>
-          <a:bodyPr wrap="square" anchor="t" lIns="45720" rIns="45720" tIns="18288" bIns="18288">
+          <a:bodyPr wrap="square" lIns="45720" tIns="18288" rIns="45720" bIns="18288" anchor="t">
             <a:spAutoFit/>
           </a:bodyPr>
           <a:lstStyle/>
@@ -5401,7 +5486,7 @@
           <a:noFill/>
         </p:spPr>
         <p:txBody>
-          <a:bodyPr wrap="square" anchor="t" lIns="45720" rIns="45720" tIns="18288" bIns="18288">
+          <a:bodyPr wrap="square" lIns="45720" tIns="18288" rIns="45720" bIns="18288" anchor="t">
             <a:spAutoFit/>
           </a:bodyPr>
           <a:lstStyle/>
@@ -5441,7 +5526,7 @@
           <a:noFill/>
         </p:spPr>
         <p:txBody>
-          <a:bodyPr wrap="square" anchor="t" lIns="45720" rIns="45720" tIns="18288" bIns="18288">
+          <a:bodyPr wrap="square" lIns="45720" tIns="18288" rIns="45720" bIns="18288" anchor="t">
             <a:spAutoFit/>
           </a:bodyPr>
           <a:lstStyle/>
@@ -5504,7 +5589,9 @@
         <p:txBody>
           <a:bodyPr rtlCol="0" anchor="ctr"/>
           <a:lstStyle/>
-          <a:p/>
+          <a:p>
+            <a:endParaRPr/>
+          </a:p>
         </p:txBody>
       </p:sp>
       <p:sp>
@@ -5546,7 +5633,9 @@
         <p:txBody>
           <a:bodyPr rtlCol="0" anchor="ctr"/>
           <a:lstStyle/>
-          <a:p/>
+          <a:p>
+            <a:endParaRPr/>
+          </a:p>
         </p:txBody>
       </p:sp>
       <p:sp>
@@ -5566,7 +5655,7 @@
           <a:noFill/>
         </p:spPr>
         <p:txBody>
-          <a:bodyPr wrap="square" anchor="t" lIns="45720" rIns="45720" tIns="18288" bIns="18288">
+          <a:bodyPr wrap="square" lIns="45720" tIns="18288" rIns="45720" bIns="18288" anchor="t">
             <a:spAutoFit/>
           </a:bodyPr>
           <a:lstStyle/>
@@ -5605,7 +5694,7 @@
           <a:noFill/>
         </p:spPr>
         <p:txBody>
-          <a:bodyPr wrap="square" anchor="t" lIns="45720" rIns="45720" tIns="18288" bIns="18288">
+          <a:bodyPr wrap="square" lIns="45720" tIns="18288" rIns="45720" bIns="18288" anchor="t">
             <a:spAutoFit/>
           </a:bodyPr>
           <a:lstStyle/>
@@ -5645,7 +5734,7 @@
           <a:noFill/>
         </p:spPr>
         <p:txBody>
-          <a:bodyPr wrap="square" anchor="t" lIns="45720" rIns="45720" tIns="18288" bIns="18288">
+          <a:bodyPr wrap="square" lIns="45720" tIns="18288" rIns="45720" bIns="18288" anchor="t">
             <a:spAutoFit/>
           </a:bodyPr>
           <a:lstStyle/>
@@ -5676,7 +5765,7 @@
 </file>
 
 <file path=ppt/slides/slide4.xml><?xml version="1.0" encoding="utf-8"?>
-<p:sld xmlns:a="http://schemas.openxmlformats.org/drawingml/2006/main" xmlns:p="http://schemas.openxmlformats.org/presentationml/2006/main" xmlns:r="http://schemas.openxmlformats.org/officeDocument/2006/relationships">
+<p:sld xmlns:a="http://schemas.openxmlformats.org/drawingml/2006/main" xmlns:r="http://schemas.openxmlformats.org/officeDocument/2006/relationships" xmlns:p="http://schemas.openxmlformats.org/presentationml/2006/main">
   <p:cSld>
     <p:bg>
       <p:bgPr>
@@ -5692,7 +5781,14 @@
         <p:cNvGrpSpPr/>
         <p:nvPr/>
       </p:nvGrpSpPr>
-      <p:grpSpPr/>
+      <p:grpSpPr>
+        <a:xfrm>
+          <a:off x="0" y="0"/>
+          <a:ext cx="0" cy="0"/>
+          <a:chOff x="0" y="0"/>
+          <a:chExt cx="0" cy="0"/>
+        </a:xfrm>
+      </p:grpSpPr>
       <p:sp>
         <p:nvSpPr>
           <p:cNvPr id="2" name="Oval 1"/>
@@ -5734,6 +5830,7 @@
           <a:lstStyle/>
           <a:p>
             <a:pPr algn="ctr"/>
+            <a:endParaRPr/>
           </a:p>
         </p:txBody>
       </p:sp>
@@ -5754,7 +5851,7 @@
           <a:noFill/>
         </p:spPr>
         <p:txBody>
-          <a:bodyPr wrap="square" anchor="t" lIns="45720" rIns="45720" tIns="18288" bIns="18288">
+          <a:bodyPr wrap="square" lIns="45720" tIns="18288" rIns="45720" bIns="18288" anchor="t">
             <a:spAutoFit/>
           </a:bodyPr>
           <a:lstStyle/>
@@ -5793,7 +5890,7 @@
           <a:noFill/>
         </p:spPr>
         <p:txBody>
-          <a:bodyPr wrap="square" anchor="t" lIns="45720" rIns="45720" tIns="18288" bIns="18288">
+          <a:bodyPr wrap="square" lIns="45720" tIns="18288" rIns="45720" bIns="18288" anchor="t">
             <a:spAutoFit/>
           </a:bodyPr>
           <a:lstStyle/>
@@ -5832,7 +5929,7 @@
           <a:noFill/>
         </p:spPr>
         <p:txBody>
-          <a:bodyPr wrap="square" anchor="t" lIns="45720" rIns="45720" tIns="18288" bIns="18288">
+          <a:bodyPr wrap="square" lIns="45720" tIns="18288" rIns="45720" bIns="18288" anchor="t">
             <a:spAutoFit/>
           </a:bodyPr>
           <a:lstStyle/>
@@ -5893,7 +5990,9 @@
         <p:txBody>
           <a:bodyPr rtlCol="0" anchor="ctr"/>
           <a:lstStyle/>
-          <a:p/>
+          <a:p>
+            <a:endParaRPr/>
+          </a:p>
         </p:txBody>
       </p:sp>
       <p:sp>
@@ -5913,7 +6012,7 @@
           <a:noFill/>
         </p:spPr>
         <p:txBody>
-          <a:bodyPr wrap="square" anchor="t" lIns="45720" rIns="45720" tIns="18288" bIns="18288">
+          <a:bodyPr wrap="square" lIns="45720" tIns="18288" rIns="45720" bIns="18288" anchor="t">
             <a:spAutoFit/>
           </a:bodyPr>
           <a:lstStyle/>
@@ -5974,7 +6073,9 @@
         <p:txBody>
           <a:bodyPr rtlCol="0" anchor="ctr"/>
           <a:lstStyle/>
-          <a:p/>
+          <a:p>
+            <a:endParaRPr/>
+          </a:p>
         </p:txBody>
       </p:sp>
       <p:sp>
@@ -5994,7 +6095,7 @@
           <a:noFill/>
         </p:spPr>
         <p:txBody>
-          <a:bodyPr wrap="square" anchor="t" lIns="45720" rIns="45720" tIns="18288" bIns="18288">
+          <a:bodyPr wrap="square" lIns="45720" tIns="18288" rIns="45720" bIns="18288" anchor="t">
             <a:spAutoFit/>
           </a:bodyPr>
           <a:lstStyle/>
@@ -6055,7 +6156,9 @@
         <p:txBody>
           <a:bodyPr rtlCol="0" anchor="ctr"/>
           <a:lstStyle/>
-          <a:p/>
+          <a:p>
+            <a:endParaRPr/>
+          </a:p>
         </p:txBody>
       </p:sp>
       <p:sp>
@@ -6075,7 +6178,7 @@
           <a:noFill/>
         </p:spPr>
         <p:txBody>
-          <a:bodyPr wrap="square" anchor="t" lIns="45720" rIns="45720" tIns="18288" bIns="18288">
+          <a:bodyPr wrap="square" lIns="45720" tIns="18288" rIns="45720" bIns="18288" anchor="t">
             <a:spAutoFit/>
           </a:bodyPr>
           <a:lstStyle/>
@@ -6136,7 +6239,9 @@
         <p:txBody>
           <a:bodyPr rtlCol="0" anchor="ctr"/>
           <a:lstStyle/>
-          <a:p/>
+          <a:p>
+            <a:endParaRPr/>
+          </a:p>
         </p:txBody>
       </p:sp>
       <p:sp>
@@ -6156,7 +6261,7 @@
           <a:noFill/>
         </p:spPr>
         <p:txBody>
-          <a:bodyPr wrap="square" anchor="t" lIns="45720" rIns="45720" tIns="18288" bIns="18288">
+          <a:bodyPr wrap="square" lIns="45720" tIns="18288" rIns="45720" bIns="18288" anchor="t">
             <a:spAutoFit/>
           </a:bodyPr>
           <a:lstStyle/>
@@ -6217,7 +6322,9 @@
         <p:txBody>
           <a:bodyPr rtlCol="0" anchor="ctr"/>
           <a:lstStyle/>
-          <a:p/>
+          <a:p>
+            <a:endParaRPr/>
+          </a:p>
         </p:txBody>
       </p:sp>
       <p:sp>
@@ -6237,7 +6344,7 @@
           <a:noFill/>
         </p:spPr>
         <p:txBody>
-          <a:bodyPr wrap="square" anchor="t" lIns="45720" rIns="45720" tIns="18288" bIns="18288">
+          <a:bodyPr wrap="square" lIns="45720" tIns="18288" rIns="45720" bIns="18288" anchor="t">
             <a:spAutoFit/>
           </a:bodyPr>
           <a:lstStyle/>
@@ -6298,7 +6405,9 @@
         <p:txBody>
           <a:bodyPr rtlCol="0" anchor="ctr"/>
           <a:lstStyle/>
-          <a:p/>
+          <a:p>
+            <a:endParaRPr/>
+          </a:p>
         </p:txBody>
       </p:sp>
       <p:sp>
@@ -6318,7 +6427,7 @@
           <a:noFill/>
         </p:spPr>
         <p:txBody>
-          <a:bodyPr wrap="square" anchor="t" lIns="45720" rIns="45720" tIns="18288" bIns="18288">
+          <a:bodyPr wrap="square" lIns="45720" tIns="18288" rIns="45720" bIns="18288" anchor="t">
             <a:spAutoFit/>
           </a:bodyPr>
           <a:lstStyle/>
@@ -6379,7 +6488,9 @@
         <p:txBody>
           <a:bodyPr rtlCol="0" anchor="ctr"/>
           <a:lstStyle/>
-          <a:p/>
+          <a:p>
+            <a:endParaRPr/>
+          </a:p>
         </p:txBody>
       </p:sp>
       <p:sp>
@@ -6399,7 +6510,7 @@
           <a:noFill/>
         </p:spPr>
         <p:txBody>
-          <a:bodyPr wrap="square" anchor="t" lIns="45720" rIns="45720" tIns="18288" bIns="18288">
+          <a:bodyPr wrap="square" lIns="45720" tIns="18288" rIns="45720" bIns="18288" anchor="t">
             <a:spAutoFit/>
           </a:bodyPr>
           <a:lstStyle/>
@@ -6462,7 +6573,9 @@
         <p:txBody>
           <a:bodyPr rtlCol="0" anchor="ctr"/>
           <a:lstStyle/>
-          <a:p/>
+          <a:p>
+            <a:endParaRPr/>
+          </a:p>
         </p:txBody>
       </p:sp>
       <p:sp>
@@ -6482,7 +6595,7 @@
           <a:noFill/>
         </p:spPr>
         <p:txBody>
-          <a:bodyPr wrap="square" anchor="t" lIns="45720" rIns="45720" tIns="18288" bIns="18288">
+          <a:bodyPr wrap="square" lIns="45720" tIns="18288" rIns="45720" bIns="18288" anchor="t">
             <a:spAutoFit/>
           </a:bodyPr>
           <a:lstStyle/>
@@ -6521,7 +6634,7 @@
           <a:noFill/>
         </p:spPr>
         <p:txBody>
-          <a:bodyPr wrap="square" anchor="t" lIns="45720" rIns="45720" tIns="18288" bIns="18288">
+          <a:bodyPr wrap="square" lIns="45720" tIns="18288" rIns="45720" bIns="18288" anchor="t">
             <a:spAutoFit/>
           </a:bodyPr>
           <a:lstStyle/>
@@ -6584,7 +6697,9 @@
         <p:txBody>
           <a:bodyPr rtlCol="0" anchor="ctr"/>
           <a:lstStyle/>
-          <a:p/>
+          <a:p>
+            <a:endParaRPr/>
+          </a:p>
         </p:txBody>
       </p:sp>
       <p:sp>
@@ -6604,7 +6719,7 @@
           <a:noFill/>
         </p:spPr>
         <p:txBody>
-          <a:bodyPr wrap="square" anchor="t" lIns="45720" rIns="45720" tIns="18288" bIns="18288">
+          <a:bodyPr wrap="square" lIns="45720" tIns="18288" rIns="45720" bIns="18288" anchor="t">
             <a:spAutoFit/>
           </a:bodyPr>
           <a:lstStyle/>
@@ -6643,7 +6758,7 @@
           <a:noFill/>
         </p:spPr>
         <p:txBody>
-          <a:bodyPr wrap="square" anchor="t" lIns="45720" rIns="45720" tIns="18288" bIns="18288">
+          <a:bodyPr wrap="square" lIns="45720" tIns="18288" rIns="45720" bIns="18288" anchor="t">
             <a:spAutoFit/>
           </a:bodyPr>
           <a:lstStyle/>
@@ -6706,7 +6821,9 @@
         <p:txBody>
           <a:bodyPr rtlCol="0" anchor="ctr"/>
           <a:lstStyle/>
-          <a:p/>
+          <a:p>
+            <a:endParaRPr/>
+          </a:p>
         </p:txBody>
       </p:sp>
       <p:sp>
@@ -6726,7 +6843,7 @@
           <a:noFill/>
         </p:spPr>
         <p:txBody>
-          <a:bodyPr wrap="square" anchor="t" lIns="45720" rIns="45720" tIns="18288" bIns="18288">
+          <a:bodyPr wrap="square" lIns="45720" tIns="18288" rIns="45720" bIns="18288" anchor="t">
             <a:spAutoFit/>
           </a:bodyPr>
           <a:lstStyle/>
@@ -6765,7 +6882,7 @@
           <a:noFill/>
         </p:spPr>
         <p:txBody>
-          <a:bodyPr wrap="square" anchor="t" lIns="45720" rIns="45720" tIns="18288" bIns="18288">
+          <a:bodyPr wrap="square" lIns="45720" tIns="18288" rIns="45720" bIns="18288" anchor="t">
             <a:spAutoFit/>
           </a:bodyPr>
           <a:lstStyle/>
@@ -6796,7 +6913,7 @@
 </file>
 
 <file path=ppt/slides/slide5.xml><?xml version="1.0" encoding="utf-8"?>
-<p:sld xmlns:a="http://schemas.openxmlformats.org/drawingml/2006/main" xmlns:p="http://schemas.openxmlformats.org/presentationml/2006/main" xmlns:r="http://schemas.openxmlformats.org/officeDocument/2006/relationships">
+<p:sld xmlns:a="http://schemas.openxmlformats.org/drawingml/2006/main" xmlns:r="http://schemas.openxmlformats.org/officeDocument/2006/relationships" xmlns:p="http://schemas.openxmlformats.org/presentationml/2006/main">
   <p:cSld>
     <p:bg>
       <p:bgPr>
@@ -6812,7 +6929,14 @@
         <p:cNvGrpSpPr/>
         <p:nvPr/>
       </p:nvGrpSpPr>
-      <p:grpSpPr/>
+      <p:grpSpPr>
+        <a:xfrm>
+          <a:off x="0" y="0"/>
+          <a:ext cx="0" cy="0"/>
+          <a:chOff x="0" y="0"/>
+          <a:chExt cx="0" cy="0"/>
+        </a:xfrm>
+      </p:grpSpPr>
       <p:sp>
         <p:nvSpPr>
           <p:cNvPr id="2" name="Oval 1"/>
@@ -6854,6 +6978,7 @@
           <a:lstStyle/>
           <a:p>
             <a:pPr algn="ctr"/>
+            <a:endParaRPr/>
           </a:p>
         </p:txBody>
       </p:sp>
@@ -6874,7 +6999,7 @@
           <a:noFill/>
         </p:spPr>
         <p:txBody>
-          <a:bodyPr wrap="square" anchor="t" lIns="45720" rIns="45720" tIns="18288" bIns="18288">
+          <a:bodyPr wrap="square" lIns="45720" tIns="18288" rIns="45720" bIns="18288" anchor="t">
             <a:spAutoFit/>
           </a:bodyPr>
           <a:lstStyle/>
@@ -6913,7 +7038,7 @@
           <a:noFill/>
         </p:spPr>
         <p:txBody>
-          <a:bodyPr wrap="square" anchor="t" lIns="45720" rIns="45720" tIns="18288" bIns="18288">
+          <a:bodyPr wrap="square" lIns="45720" tIns="18288" rIns="45720" bIns="18288" anchor="t">
             <a:spAutoFit/>
           </a:bodyPr>
           <a:lstStyle/>
@@ -6952,7 +7077,7 @@
           <a:noFill/>
         </p:spPr>
         <p:txBody>
-          <a:bodyPr wrap="square" anchor="t" lIns="45720" rIns="45720" tIns="18288" bIns="18288">
+          <a:bodyPr wrap="square" lIns="45720" tIns="18288" rIns="45720" bIns="18288" anchor="t">
             <a:spAutoFit/>
           </a:bodyPr>
           <a:lstStyle/>
@@ -7045,7 +7170,9 @@
         <p:txBody>
           <a:bodyPr rtlCol="0" anchor="ctr"/>
           <a:lstStyle/>
-          <a:p/>
+          <a:p>
+            <a:endParaRPr/>
+          </a:p>
         </p:txBody>
       </p:sp>
       <p:sp>
@@ -7065,7 +7192,7 @@
           <a:noFill/>
         </p:spPr>
         <p:txBody>
-          <a:bodyPr wrap="square" anchor="t" lIns="45720" rIns="45720" tIns="18288" bIns="18288">
+          <a:bodyPr wrap="square" lIns="45720" tIns="18288" rIns="45720" bIns="18288" anchor="t">
             <a:spAutoFit/>
           </a:bodyPr>
           <a:lstStyle/>
@@ -7104,7 +7231,7 @@
           <a:noFill/>
         </p:spPr>
         <p:txBody>
-          <a:bodyPr wrap="square" anchor="t" lIns="45720" rIns="45720" tIns="18288" bIns="18288">
+          <a:bodyPr wrap="square" lIns="45720" tIns="18288" rIns="45720" bIns="18288" anchor="t">
             <a:spAutoFit/>
           </a:bodyPr>
           <a:lstStyle/>
@@ -7165,7 +7292,9 @@
         <p:txBody>
           <a:bodyPr rtlCol="0" anchor="ctr"/>
           <a:lstStyle/>
-          <a:p/>
+          <a:p>
+            <a:endParaRPr/>
+          </a:p>
         </p:txBody>
       </p:sp>
       <p:sp>
@@ -7185,7 +7314,7 @@
           <a:noFill/>
         </p:spPr>
         <p:txBody>
-          <a:bodyPr wrap="square" anchor="t" lIns="45720" rIns="45720" tIns="18288" bIns="18288">
+          <a:bodyPr wrap="square" lIns="45720" tIns="18288" rIns="45720" bIns="18288" anchor="t">
             <a:spAutoFit/>
           </a:bodyPr>
           <a:lstStyle/>
@@ -7224,7 +7353,7 @@
           <a:noFill/>
         </p:spPr>
         <p:txBody>
-          <a:bodyPr wrap="square" anchor="t" lIns="45720" rIns="45720" tIns="18288" bIns="18288">
+          <a:bodyPr wrap="square" lIns="45720" tIns="18288" rIns="45720" bIns="18288" anchor="t">
             <a:spAutoFit/>
           </a:bodyPr>
           <a:lstStyle/>
@@ -7319,7 +7448,7 @@
 </file>
 
 <file path=ppt/slides/slide6.xml><?xml version="1.0" encoding="utf-8"?>
-<p:sld xmlns:a="http://schemas.openxmlformats.org/drawingml/2006/main" xmlns:p="http://schemas.openxmlformats.org/presentationml/2006/main" xmlns:r="http://schemas.openxmlformats.org/officeDocument/2006/relationships">
+<p:sld xmlns:a="http://schemas.openxmlformats.org/drawingml/2006/main" xmlns:r="http://schemas.openxmlformats.org/officeDocument/2006/relationships" xmlns:p="http://schemas.openxmlformats.org/presentationml/2006/main">
   <p:cSld>
     <p:bg>
       <p:bgPr>
@@ -7335,7 +7464,14 @@
         <p:cNvGrpSpPr/>
         <p:nvPr/>
       </p:nvGrpSpPr>
-      <p:grpSpPr/>
+      <p:grpSpPr>
+        <a:xfrm>
+          <a:off x="0" y="0"/>
+          <a:ext cx="0" cy="0"/>
+          <a:chOff x="0" y="0"/>
+          <a:chExt cx="0" cy="0"/>
+        </a:xfrm>
+      </p:grpSpPr>
       <p:sp>
         <p:nvSpPr>
           <p:cNvPr id="2" name="Oval 1"/>
@@ -7377,6 +7513,7 @@
           <a:lstStyle/>
           <a:p>
             <a:pPr algn="ctr"/>
+            <a:endParaRPr/>
           </a:p>
         </p:txBody>
       </p:sp>
@@ -7397,7 +7534,7 @@
           <a:noFill/>
         </p:spPr>
         <p:txBody>
-          <a:bodyPr wrap="square" anchor="t" lIns="45720" rIns="45720" tIns="18288" bIns="18288">
+          <a:bodyPr wrap="square" lIns="45720" tIns="18288" rIns="45720" bIns="18288" anchor="t">
             <a:spAutoFit/>
           </a:bodyPr>
           <a:lstStyle/>
@@ -7436,7 +7573,7 @@
           <a:noFill/>
         </p:spPr>
         <p:txBody>
-          <a:bodyPr wrap="square" anchor="t" lIns="45720" rIns="45720" tIns="18288" bIns="18288">
+          <a:bodyPr wrap="square" lIns="45720" tIns="18288" rIns="45720" bIns="18288" anchor="t">
             <a:spAutoFit/>
           </a:bodyPr>
           <a:lstStyle/>
@@ -7475,7 +7612,7 @@
           <a:noFill/>
         </p:spPr>
         <p:txBody>
-          <a:bodyPr wrap="square" anchor="t" lIns="45720" rIns="45720" tIns="18288" bIns="18288">
+          <a:bodyPr wrap="square" lIns="45720" tIns="18288" rIns="45720" bIns="18288" anchor="t">
             <a:spAutoFit/>
           </a:bodyPr>
           <a:lstStyle/>
@@ -7514,7 +7651,7 @@
           <a:noFill/>
         </p:spPr>
         <p:txBody>
-          <a:bodyPr wrap="square" anchor="t" lIns="45720" rIns="45720" tIns="18288" bIns="18288">
+          <a:bodyPr wrap="square" lIns="45720" tIns="18288" rIns="45720" bIns="18288" anchor="t">
             <a:spAutoFit/>
           </a:bodyPr>
           <a:lstStyle/>
@@ -7575,7 +7712,9 @@
         <p:txBody>
           <a:bodyPr rtlCol="0" anchor="ctr"/>
           <a:lstStyle/>
-          <a:p/>
+          <a:p>
+            <a:endParaRPr/>
+          </a:p>
         </p:txBody>
       </p:sp>
       <p:sp>
@@ -7617,7 +7756,9 @@
         <p:txBody>
           <a:bodyPr rtlCol="0" anchor="ctr"/>
           <a:lstStyle/>
-          <a:p/>
+          <a:p>
+            <a:endParaRPr/>
+          </a:p>
         </p:txBody>
       </p:sp>
       <p:sp>
@@ -7637,7 +7778,7 @@
           <a:noFill/>
         </p:spPr>
         <p:txBody>
-          <a:bodyPr wrap="square" anchor="ctr" lIns="45720" rIns="45720" tIns="18288" bIns="18288">
+          <a:bodyPr wrap="square" lIns="45720" tIns="18288" rIns="45720" bIns="18288" anchor="ctr">
             <a:spAutoFit/>
           </a:bodyPr>
           <a:lstStyle/>
@@ -7676,7 +7817,7 @@
           <a:noFill/>
         </p:spPr>
         <p:txBody>
-          <a:bodyPr wrap="square" anchor="t" lIns="45720" rIns="45720" tIns="18288" bIns="18288">
+          <a:bodyPr wrap="square" lIns="45720" tIns="18288" rIns="45720" bIns="18288" anchor="t">
             <a:spAutoFit/>
           </a:bodyPr>
           <a:lstStyle/>
@@ -7737,7 +7878,9 @@
         <p:txBody>
           <a:bodyPr rtlCol="0" anchor="ctr"/>
           <a:lstStyle/>
-          <a:p/>
+          <a:p>
+            <a:endParaRPr/>
+          </a:p>
         </p:txBody>
       </p:sp>
       <p:sp>
@@ -7779,7 +7922,9 @@
         <p:txBody>
           <a:bodyPr rtlCol="0" anchor="ctr"/>
           <a:lstStyle/>
-          <a:p/>
+          <a:p>
+            <a:endParaRPr/>
+          </a:p>
         </p:txBody>
       </p:sp>
       <p:sp>
@@ -7799,7 +7944,7 @@
           <a:noFill/>
         </p:spPr>
         <p:txBody>
-          <a:bodyPr wrap="square" anchor="ctr" lIns="45720" rIns="45720" tIns="18288" bIns="18288">
+          <a:bodyPr wrap="square" lIns="45720" tIns="18288" rIns="45720" bIns="18288" anchor="ctr">
             <a:spAutoFit/>
           </a:bodyPr>
           <a:lstStyle/>
@@ -7838,7 +7983,7 @@
           <a:noFill/>
         </p:spPr>
         <p:txBody>
-          <a:bodyPr wrap="square" anchor="t" lIns="45720" rIns="45720" tIns="18288" bIns="18288">
+          <a:bodyPr wrap="square" lIns="45720" tIns="18288" rIns="45720" bIns="18288" anchor="t">
             <a:spAutoFit/>
           </a:bodyPr>
           <a:lstStyle/>
@@ -7899,7 +8044,9 @@
         <p:txBody>
           <a:bodyPr rtlCol="0" anchor="ctr"/>
           <a:lstStyle/>
-          <a:p/>
+          <a:p>
+            <a:endParaRPr/>
+          </a:p>
         </p:txBody>
       </p:sp>
       <p:sp>
@@ -7941,7 +8088,9 @@
         <p:txBody>
           <a:bodyPr rtlCol="0" anchor="ctr"/>
           <a:lstStyle/>
-          <a:p/>
+          <a:p>
+            <a:endParaRPr/>
+          </a:p>
         </p:txBody>
       </p:sp>
       <p:sp>
@@ -7961,7 +8110,7 @@
           <a:noFill/>
         </p:spPr>
         <p:txBody>
-          <a:bodyPr wrap="square" anchor="ctr" lIns="45720" rIns="45720" tIns="18288" bIns="18288">
+          <a:bodyPr wrap="square" lIns="45720" tIns="18288" rIns="45720" bIns="18288" anchor="ctr">
             <a:spAutoFit/>
           </a:bodyPr>
           <a:lstStyle/>
@@ -8000,7 +8149,7 @@
           <a:noFill/>
         </p:spPr>
         <p:txBody>
-          <a:bodyPr wrap="square" anchor="t" lIns="45720" rIns="45720" tIns="18288" bIns="18288">
+          <a:bodyPr wrap="square" lIns="45720" tIns="18288" rIns="45720" bIns="18288" anchor="t">
             <a:spAutoFit/>
           </a:bodyPr>
           <a:lstStyle/>
@@ -8061,7 +8210,9 @@
         <p:txBody>
           <a:bodyPr rtlCol="0" anchor="ctr"/>
           <a:lstStyle/>
-          <a:p/>
+          <a:p>
+            <a:endParaRPr/>
+          </a:p>
         </p:txBody>
       </p:sp>
       <p:sp>
@@ -8103,7 +8254,9 @@
         <p:txBody>
           <a:bodyPr rtlCol="0" anchor="ctr"/>
           <a:lstStyle/>
-          <a:p/>
+          <a:p>
+            <a:endParaRPr/>
+          </a:p>
         </p:txBody>
       </p:sp>
       <p:sp>
@@ -8123,7 +8276,7 @@
           <a:noFill/>
         </p:spPr>
         <p:txBody>
-          <a:bodyPr wrap="square" anchor="ctr" lIns="45720" rIns="45720" tIns="18288" bIns="18288">
+          <a:bodyPr wrap="square" lIns="45720" tIns="18288" rIns="45720" bIns="18288" anchor="ctr">
             <a:spAutoFit/>
           </a:bodyPr>
           <a:lstStyle/>
@@ -8162,7 +8315,7 @@
           <a:noFill/>
         </p:spPr>
         <p:txBody>
-          <a:bodyPr wrap="square" anchor="t" lIns="45720" rIns="45720" tIns="18288" bIns="18288">
+          <a:bodyPr wrap="square" lIns="45720" tIns="18288" rIns="45720" bIns="18288" anchor="t">
             <a:spAutoFit/>
           </a:bodyPr>
           <a:lstStyle/>
@@ -8223,7 +8376,9 @@
         <p:txBody>
           <a:bodyPr rtlCol="0" anchor="ctr"/>
           <a:lstStyle/>
-          <a:p/>
+          <a:p>
+            <a:endParaRPr/>
+          </a:p>
         </p:txBody>
       </p:sp>
       <p:sp>
@@ -8265,7 +8420,9 @@
         <p:txBody>
           <a:bodyPr rtlCol="0" anchor="ctr"/>
           <a:lstStyle/>
-          <a:p/>
+          <a:p>
+            <a:endParaRPr/>
+          </a:p>
         </p:txBody>
       </p:sp>
       <p:sp>
@@ -8285,7 +8442,7 @@
           <a:noFill/>
         </p:spPr>
         <p:txBody>
-          <a:bodyPr wrap="square" anchor="ctr" lIns="45720" rIns="45720" tIns="18288" bIns="18288">
+          <a:bodyPr wrap="square" lIns="45720" tIns="18288" rIns="45720" bIns="18288" anchor="ctr">
             <a:spAutoFit/>
           </a:bodyPr>
           <a:lstStyle/>
@@ -8316,7 +8473,7 @@
 </file>
 
 <file path=ppt/slides/slide7.xml><?xml version="1.0" encoding="utf-8"?>
-<p:sld xmlns:a="http://schemas.openxmlformats.org/drawingml/2006/main" xmlns:p="http://schemas.openxmlformats.org/presentationml/2006/main" xmlns:r="http://schemas.openxmlformats.org/officeDocument/2006/relationships">
+<p:sld xmlns:a="http://schemas.openxmlformats.org/drawingml/2006/main" xmlns:r="http://schemas.openxmlformats.org/officeDocument/2006/relationships" xmlns:p="http://schemas.openxmlformats.org/presentationml/2006/main">
   <p:cSld>
     <p:bg>
       <p:bgPr>
@@ -8332,7 +8489,14 @@
         <p:cNvGrpSpPr/>
         <p:nvPr/>
       </p:nvGrpSpPr>
-      <p:grpSpPr/>
+      <p:grpSpPr>
+        <a:xfrm>
+          <a:off x="0" y="0"/>
+          <a:ext cx="0" cy="0"/>
+          <a:chOff x="0" y="0"/>
+          <a:chExt cx="0" cy="0"/>
+        </a:xfrm>
+      </p:grpSpPr>
       <p:sp>
         <p:nvSpPr>
           <p:cNvPr id="2" name="Oval 1"/>
@@ -8374,6 +8538,7 @@
           <a:lstStyle/>
           <a:p>
             <a:pPr algn="ctr"/>
+            <a:endParaRPr/>
           </a:p>
         </p:txBody>
       </p:sp>
@@ -8394,7 +8559,7 @@
           <a:noFill/>
         </p:spPr>
         <p:txBody>
-          <a:bodyPr wrap="square" anchor="t" lIns="45720" rIns="45720" tIns="18288" bIns="18288">
+          <a:bodyPr wrap="square" lIns="45720" tIns="18288" rIns="45720" bIns="18288" anchor="t">
             <a:spAutoFit/>
           </a:bodyPr>
           <a:lstStyle/>
@@ -8433,7 +8598,7 @@
           <a:noFill/>
         </p:spPr>
         <p:txBody>
-          <a:bodyPr wrap="square" anchor="t" lIns="45720" rIns="45720" tIns="18288" bIns="18288">
+          <a:bodyPr wrap="square" lIns="45720" tIns="18288" rIns="45720" bIns="18288" anchor="t">
             <a:spAutoFit/>
           </a:bodyPr>
           <a:lstStyle/>
@@ -8472,7 +8637,7 @@
           <a:noFill/>
         </p:spPr>
         <p:txBody>
-          <a:bodyPr wrap="square" anchor="t" lIns="45720" rIns="45720" tIns="18288" bIns="18288">
+          <a:bodyPr wrap="square" lIns="45720" tIns="18288" rIns="45720" bIns="18288" anchor="t">
             <a:spAutoFit/>
           </a:bodyPr>
           <a:lstStyle/>
@@ -8543,7 +8708,7 @@
           <a:noFill/>
         </p:spPr>
         <p:txBody>
-          <a:bodyPr wrap="square" anchor="t" lIns="45720" rIns="45720" tIns="18288" bIns="18288">
+          <a:bodyPr wrap="square" lIns="45720" tIns="18288" rIns="45720" bIns="18288" anchor="t">
             <a:spAutoFit/>
           </a:bodyPr>
           <a:lstStyle/>
@@ -8606,7 +8771,9 @@
         <p:txBody>
           <a:bodyPr rtlCol="0" anchor="ctr"/>
           <a:lstStyle/>
-          <a:p/>
+          <a:p>
+            <a:endParaRPr/>
+          </a:p>
         </p:txBody>
       </p:sp>
       <p:sp>
@@ -8626,7 +8793,7 @@
           <a:noFill/>
         </p:spPr>
         <p:txBody>
-          <a:bodyPr wrap="square" anchor="t" lIns="45720" rIns="45720" tIns="18288" bIns="18288">
+          <a:bodyPr wrap="square" lIns="45720" tIns="18288" rIns="45720" bIns="18288" anchor="t">
             <a:spAutoFit/>
           </a:bodyPr>
           <a:lstStyle/>
@@ -8665,7 +8832,7 @@
           <a:noFill/>
         </p:spPr>
         <p:txBody>
-          <a:bodyPr wrap="square" anchor="t" lIns="45720" rIns="45720" tIns="18288" bIns="18288">
+          <a:bodyPr wrap="square" lIns="45720" tIns="18288" rIns="45720" bIns="18288" anchor="t">
             <a:spAutoFit/>
           </a:bodyPr>
           <a:lstStyle/>
@@ -8704,7 +8871,7 @@
           <a:noFill/>
         </p:spPr>
         <p:txBody>
-          <a:bodyPr wrap="square" anchor="t" lIns="45720" rIns="45720" tIns="18288" bIns="18288">
+          <a:bodyPr wrap="square" lIns="45720" tIns="18288" rIns="45720" bIns="18288" anchor="t">
             <a:spAutoFit/>
           </a:bodyPr>
           <a:lstStyle/>
@@ -8743,7 +8910,7 @@
           <a:noFill/>
         </p:spPr>
         <p:txBody>
-          <a:bodyPr wrap="square" anchor="t" lIns="45720" rIns="45720" tIns="18288" bIns="18288">
+          <a:bodyPr wrap="square" lIns="45720" tIns="18288" rIns="45720" bIns="18288" anchor="t">
             <a:spAutoFit/>
           </a:bodyPr>
           <a:lstStyle/>
@@ -8774,7 +8941,7 @@
 </file>
 
 <file path=ppt/slides/slide8.xml><?xml version="1.0" encoding="utf-8"?>
-<p:sld xmlns:a="http://schemas.openxmlformats.org/drawingml/2006/main" xmlns:p="http://schemas.openxmlformats.org/presentationml/2006/main" xmlns:r="http://schemas.openxmlformats.org/officeDocument/2006/relationships">
+<p:sld xmlns:a="http://schemas.openxmlformats.org/drawingml/2006/main" xmlns:r="http://schemas.openxmlformats.org/officeDocument/2006/relationships" xmlns:p="http://schemas.openxmlformats.org/presentationml/2006/main">
   <p:cSld>
     <p:bg>
       <p:bgPr>
@@ -8790,7 +8957,14 @@
         <p:cNvGrpSpPr/>
         <p:nvPr/>
       </p:nvGrpSpPr>
-      <p:grpSpPr/>
+      <p:grpSpPr>
+        <a:xfrm>
+          <a:off x="0" y="0"/>
+          <a:ext cx="0" cy="0"/>
+          <a:chOff x="0" y="0"/>
+          <a:chExt cx="0" cy="0"/>
+        </a:xfrm>
+      </p:grpSpPr>
       <p:sp>
         <p:nvSpPr>
           <p:cNvPr id="2" name="Oval 1"/>
@@ -8832,6 +9006,7 @@
           <a:lstStyle/>
           <a:p>
             <a:pPr algn="ctr"/>
+            <a:endParaRPr/>
           </a:p>
         </p:txBody>
       </p:sp>
@@ -8852,7 +9027,7 @@
           <a:noFill/>
         </p:spPr>
         <p:txBody>
-          <a:bodyPr wrap="square" anchor="t" lIns="45720" rIns="45720" tIns="18288" bIns="18288">
+          <a:bodyPr wrap="square" lIns="45720" tIns="18288" rIns="45720" bIns="18288" anchor="t">
             <a:spAutoFit/>
           </a:bodyPr>
           <a:lstStyle/>
@@ -8891,7 +9066,7 @@
           <a:noFill/>
         </p:spPr>
         <p:txBody>
-          <a:bodyPr wrap="square" anchor="t" lIns="45720" rIns="45720" tIns="18288" bIns="18288">
+          <a:bodyPr wrap="square" lIns="45720" tIns="18288" rIns="45720" bIns="18288" anchor="t">
             <a:spAutoFit/>
           </a:bodyPr>
           <a:lstStyle/>
@@ -8930,7 +9105,7 @@
           <a:noFill/>
         </p:spPr>
         <p:txBody>
-          <a:bodyPr wrap="square" anchor="t" lIns="45720" rIns="45720" tIns="18288" bIns="18288">
+          <a:bodyPr wrap="square" lIns="45720" tIns="18288" rIns="45720" bIns="18288" anchor="t">
             <a:spAutoFit/>
           </a:bodyPr>
           <a:lstStyle/>
@@ -8993,7 +9168,9 @@
         <p:txBody>
           <a:bodyPr rtlCol="0" anchor="ctr"/>
           <a:lstStyle/>
-          <a:p/>
+          <a:p>
+            <a:endParaRPr/>
+          </a:p>
         </p:txBody>
       </p:sp>
       <p:sp>
@@ -9035,7 +9212,9 @@
         <p:txBody>
           <a:bodyPr rtlCol="0" anchor="ctr"/>
           <a:lstStyle/>
-          <a:p/>
+          <a:p>
+            <a:endParaRPr/>
+          </a:p>
         </p:txBody>
       </p:sp>
       <p:sp>
@@ -9055,7 +9234,7 @@
           <a:noFill/>
         </p:spPr>
         <p:txBody>
-          <a:bodyPr wrap="square" anchor="t" lIns="45720" rIns="45720" tIns="18288" bIns="18288">
+          <a:bodyPr wrap="square" lIns="45720" tIns="18288" rIns="45720" bIns="18288" anchor="t">
             <a:spAutoFit/>
           </a:bodyPr>
           <a:lstStyle/>
@@ -9094,7 +9273,7 @@
           <a:noFill/>
         </p:spPr>
         <p:txBody>
-          <a:bodyPr wrap="square" anchor="t" lIns="45720" rIns="45720" tIns="18288" bIns="18288">
+          <a:bodyPr wrap="square" lIns="45720" tIns="18288" rIns="45720" bIns="18288" anchor="t">
             <a:spAutoFit/>
           </a:bodyPr>
           <a:lstStyle/>
@@ -9157,7 +9336,9 @@
         <p:txBody>
           <a:bodyPr rtlCol="0" anchor="ctr"/>
           <a:lstStyle/>
-          <a:p/>
+          <a:p>
+            <a:endParaRPr/>
+          </a:p>
         </p:txBody>
       </p:sp>
       <p:sp>
@@ -9199,7 +9380,9 @@
         <p:txBody>
           <a:bodyPr rtlCol="0" anchor="ctr"/>
           <a:lstStyle/>
-          <a:p/>
+          <a:p>
+            <a:endParaRPr/>
+          </a:p>
         </p:txBody>
       </p:sp>
       <p:sp>
@@ -9219,7 +9402,7 @@
           <a:noFill/>
         </p:spPr>
         <p:txBody>
-          <a:bodyPr wrap="square" anchor="t" lIns="45720" rIns="45720" tIns="18288" bIns="18288">
+          <a:bodyPr wrap="square" lIns="45720" tIns="18288" rIns="45720" bIns="18288" anchor="t">
             <a:spAutoFit/>
           </a:bodyPr>
           <a:lstStyle/>
@@ -9258,7 +9441,7 @@
           <a:noFill/>
         </p:spPr>
         <p:txBody>
-          <a:bodyPr wrap="square" anchor="t" lIns="45720" rIns="45720" tIns="18288" bIns="18288">
+          <a:bodyPr wrap="square" lIns="45720" tIns="18288" rIns="45720" bIns="18288" anchor="t">
             <a:spAutoFit/>
           </a:bodyPr>
           <a:lstStyle/>
@@ -9321,7 +9504,9 @@
         <p:txBody>
           <a:bodyPr rtlCol="0" anchor="ctr"/>
           <a:lstStyle/>
-          <a:p/>
+          <a:p>
+            <a:endParaRPr/>
+          </a:p>
         </p:txBody>
       </p:sp>
       <p:sp>
@@ -9363,7 +9548,9 @@
         <p:txBody>
           <a:bodyPr rtlCol="0" anchor="ctr"/>
           <a:lstStyle/>
-          <a:p/>
+          <a:p>
+            <a:endParaRPr/>
+          </a:p>
         </p:txBody>
       </p:sp>
       <p:sp>
@@ -9383,7 +9570,7 @@
           <a:noFill/>
         </p:spPr>
         <p:txBody>
-          <a:bodyPr wrap="square" anchor="t" lIns="45720" rIns="45720" tIns="18288" bIns="18288">
+          <a:bodyPr wrap="square" lIns="45720" tIns="18288" rIns="45720" bIns="18288" anchor="t">
             <a:spAutoFit/>
           </a:bodyPr>
           <a:lstStyle/>
@@ -9422,7 +9609,7 @@
           <a:noFill/>
         </p:spPr>
         <p:txBody>
-          <a:bodyPr wrap="square" anchor="t" lIns="45720" rIns="45720" tIns="18288" bIns="18288">
+          <a:bodyPr wrap="square" lIns="45720" tIns="18288" rIns="45720" bIns="18288" anchor="t">
             <a:spAutoFit/>
           </a:bodyPr>
           <a:lstStyle/>
@@ -9461,7 +9648,7 @@
           <a:noFill/>
         </p:spPr>
         <p:txBody>
-          <a:bodyPr wrap="square" anchor="t" lIns="45720" rIns="45720" tIns="18288" bIns="18288">
+          <a:bodyPr wrap="square" lIns="45720" tIns="18288" rIns="45720" bIns="18288" anchor="t">
             <a:spAutoFit/>
           </a:bodyPr>
           <a:lstStyle/>
@@ -9522,7 +9709,9 @@
         <p:txBody>
           <a:bodyPr rtlCol="0" anchor="ctr"/>
           <a:lstStyle/>
-          <a:p/>
+          <a:p>
+            <a:endParaRPr/>
+          </a:p>
         </p:txBody>
       </p:sp>
       <p:sp>
@@ -9542,7 +9731,7 @@
           <a:noFill/>
         </p:spPr>
         <p:txBody>
-          <a:bodyPr wrap="square" anchor="t" lIns="45720" rIns="45720" tIns="18288" bIns="18288">
+          <a:bodyPr wrap="square" lIns="45720" tIns="18288" rIns="45720" bIns="18288" anchor="t">
             <a:spAutoFit/>
           </a:bodyPr>
           <a:lstStyle/>
@@ -9581,7 +9770,7 @@
           <a:noFill/>
         </p:spPr>
         <p:txBody>
-          <a:bodyPr wrap="square" anchor="t" lIns="45720" rIns="45720" tIns="18288" bIns="18288">
+          <a:bodyPr wrap="square" lIns="45720" tIns="18288" rIns="45720" bIns="18288" anchor="t">
             <a:spAutoFit/>
           </a:bodyPr>
           <a:lstStyle/>
@@ -9620,7 +9809,7 @@
           <a:noFill/>
         </p:spPr>
         <p:txBody>
-          <a:bodyPr wrap="square" anchor="t" lIns="45720" rIns="45720" tIns="18288" bIns="18288">
+          <a:bodyPr wrap="square" lIns="45720" tIns="18288" rIns="45720" bIns="18288" anchor="t">
             <a:spAutoFit/>
           </a:bodyPr>
           <a:lstStyle/>
@@ -9651,7 +9840,7 @@
 </file>
 
 <file path=ppt/slides/slide9.xml><?xml version="1.0" encoding="utf-8"?>
-<p:sld xmlns:a="http://schemas.openxmlformats.org/drawingml/2006/main" xmlns:p="http://schemas.openxmlformats.org/presentationml/2006/main" xmlns:r="http://schemas.openxmlformats.org/officeDocument/2006/relationships">
+<p:sld xmlns:a="http://schemas.openxmlformats.org/drawingml/2006/main" xmlns:r="http://schemas.openxmlformats.org/officeDocument/2006/relationships" xmlns:p="http://schemas.openxmlformats.org/presentationml/2006/main">
   <p:cSld>
     <p:bg>
       <p:bgPr>
@@ -9667,7 +9856,14 @@
         <p:cNvGrpSpPr/>
         <p:nvPr/>
       </p:nvGrpSpPr>
-      <p:grpSpPr/>
+      <p:grpSpPr>
+        <a:xfrm>
+          <a:off x="0" y="0"/>
+          <a:ext cx="0" cy="0"/>
+          <a:chOff x="0" y="0"/>
+          <a:chExt cx="0" cy="0"/>
+        </a:xfrm>
+      </p:grpSpPr>
       <p:sp>
         <p:nvSpPr>
           <p:cNvPr id="2" name="Oval 1"/>
@@ -9709,6 +9905,7 @@
           <a:lstStyle/>
           <a:p>
             <a:pPr algn="ctr"/>
+            <a:endParaRPr/>
           </a:p>
         </p:txBody>
       </p:sp>
@@ -9729,7 +9926,7 @@
           <a:noFill/>
         </p:spPr>
         <p:txBody>
-          <a:bodyPr wrap="square" anchor="t" lIns="45720" rIns="45720" tIns="18288" bIns="18288">
+          <a:bodyPr wrap="square" lIns="45720" tIns="18288" rIns="45720" bIns="18288" anchor="t">
             <a:spAutoFit/>
           </a:bodyPr>
           <a:lstStyle/>
@@ -9768,7 +9965,7 @@
           <a:noFill/>
         </p:spPr>
         <p:txBody>
-          <a:bodyPr wrap="square" anchor="t" lIns="45720" rIns="45720" tIns="18288" bIns="18288">
+          <a:bodyPr wrap="square" lIns="45720" tIns="18288" rIns="45720" bIns="18288" anchor="t">
             <a:spAutoFit/>
           </a:bodyPr>
           <a:lstStyle/>
@@ -9807,7 +10004,7 @@
           <a:noFill/>
         </p:spPr>
         <p:txBody>
-          <a:bodyPr wrap="square" anchor="t" lIns="45720" rIns="45720" tIns="18288" bIns="18288">
+          <a:bodyPr wrap="square" lIns="45720" tIns="18288" rIns="45720" bIns="18288" anchor="t">
             <a:spAutoFit/>
           </a:bodyPr>
           <a:lstStyle/>
@@ -9870,7 +10067,9 @@
         <p:txBody>
           <a:bodyPr rtlCol="0" anchor="ctr"/>
           <a:lstStyle/>
-          <a:p/>
+          <a:p>
+            <a:endParaRPr/>
+          </a:p>
         </p:txBody>
       </p:sp>
       <p:sp>
@@ -9890,7 +10089,7 @@
           <a:noFill/>
         </p:spPr>
         <p:txBody>
-          <a:bodyPr wrap="square" anchor="t" lIns="45720" rIns="45720" tIns="18288" bIns="18288">
+          <a:bodyPr wrap="square" lIns="45720" tIns="18288" rIns="45720" bIns="18288" anchor="t">
             <a:spAutoFit/>
           </a:bodyPr>
           <a:lstStyle/>
@@ -9929,7 +10128,7 @@
           <a:noFill/>
         </p:spPr>
         <p:txBody>
-          <a:bodyPr wrap="square" anchor="t" lIns="45720" rIns="45720" tIns="18288" bIns="18288">
+          <a:bodyPr wrap="square" lIns="45720" tIns="18288" rIns="45720" bIns="18288" anchor="t">
             <a:spAutoFit/>
           </a:bodyPr>
           <a:lstStyle/>
@@ -10000,7 +10199,7 @@
           <a:noFill/>
         </p:spPr>
         <p:txBody>
-          <a:bodyPr wrap="square" anchor="t" lIns="45720" rIns="45720" tIns="18288" bIns="18288">
+          <a:bodyPr wrap="square" lIns="45720" tIns="18288" rIns="45720" bIns="18288" anchor="t">
             <a:spAutoFit/>
           </a:bodyPr>
           <a:lstStyle/>
@@ -10039,7 +10238,7 @@
           <a:noFill/>
         </p:spPr>
         <p:txBody>
-          <a:bodyPr wrap="square" anchor="t" lIns="45720" rIns="45720" tIns="18288" bIns="18288">
+          <a:bodyPr wrap="square" lIns="45720" tIns="18288" rIns="45720" bIns="18288" anchor="t">
             <a:spAutoFit/>
           </a:bodyPr>
           <a:lstStyle/>
@@ -10078,7 +10277,7 @@
           <a:noFill/>
         </p:spPr>
         <p:txBody>
-          <a:bodyPr wrap="square" anchor="t" lIns="45720" rIns="45720" tIns="18288" bIns="18288">
+          <a:bodyPr wrap="square" lIns="45720" tIns="18288" rIns="45720" bIns="18288" anchor="t">
             <a:spAutoFit/>
           </a:bodyPr>
           <a:lstStyle/>

</xml_diff>